<commit_message>
docs: measured numbers in README and deck; witness marked Built; Act 2 cites stage8-act2
</commit_message>
<xml_diff>
--- a/docs/deck/saakshi.pptx
+++ b/docs/deck/saakshi.pptx
@@ -18,9 +18,10 @@
     <p:sldId id="266" r:id="rId12"/>
     <p:sldId id="267" r:id="rId13"/>
     <p:sldId id="268" r:id="rId14"/>
+    <p:sldId id="269" r:id="rId15"/>
   </p:sldIdLst>
   <p:notesMasterIdLst>
-    <p:notesMasterId r:id="rId15"/>
+    <p:notesMasterId r:id="rId16"/>
   </p:notesMasterIdLst>
   <p:sldSz cx="9144000" cy="5143500"/>
   <p:notesSz cx="5143500" cy="9144000"/>
@@ -778,7 +779,7 @@
           <a:p>
             <a:r>
               <a:rPr lang="en-US" dirty="0"/>
-              <a:t>[2:40–2:50] Close. We are not asking NTA to buy our software; we are offering a protocol and a conformance kit to write into the RFP. Cost per candidate is a Stage 7 measurement — we will not quote a number we have not measured.</a:t>
+              <a:t>Measured numbers, all from docs/evidence. One Mac, loopback, synthetic G1 cohort at 20,000 candidates. Bytes per candidate-hour extrapolates a 60-second window and is not a real exam duty cycle. Seat CPU and memory cover the Node main process only. Chaos: 20 of 20 runs passed, 16,000 sent and stored, RTO medians 1.22 to 1.23 s for kill and wipe and 0.955 s for spare relay.</a:t>
             </a:r>
             <a:endParaRPr lang="en-US" dirty="0"/>
           </a:p>
@@ -866,7 +867,7 @@
           <a:p>
             <a:r>
               <a:rPr lang="en-US" dirty="0"/>
-              <a:t>[2:50–3:00] Every one of the 12 focus areas maps to features, code and tests in traceability.md — seven built, five partly built with the remaining stage named. Thank you — happy to break anything live.</a:t>
+              <a:t>[2:40–2:50] Close. We are not asking NTA to buy our software; we are offering a protocol and a conformance kit to write into the RFP. Cost per candidate is a Stage 7 measurement — we will not quote a number we have not measured.</a:t>
             </a:r>
             <a:endParaRPr lang="en-US" dirty="0"/>
           </a:p>
@@ -890,6 +891,94 @@
             <a:fld id="{F7021451-1387-4CA6-816F-3879F97B5CBC}" type="slidenum">
               <a:rPr lang="en-US"/>
               <a:t>13</a:t>
+            </a:fld>
+            <a:endParaRPr lang="en-US"/>
+          </a:p>
+        </p:txBody>
+      </p:sp>
+    </p:spTree>
+    <p:extLst>
+      <p:ext uri="{BB962C8B-B14F-4D97-AF65-F5344CB8AC3E}">
+        <p14:creationId xmlns:p14="http://schemas.microsoft.com/office/powerpoint/2010/main" val="1024086991"/>
+      </p:ext>
+    </p:extLst>
+  </p:cSld>
+  <p:clrMapOvr>
+    <a:masterClrMapping/>
+  </p:clrMapOvr>
+</p:notes>
+</file>
+
+<file path=ppt/notesSlides/notesSlide14.xml><?xml version="1.0" encoding="utf-8"?>
+<p:notes xmlns:a="http://schemas.openxmlformats.org/drawingml/2006/main" xmlns:r="http://schemas.openxmlformats.org/officeDocument/2006/relationships" xmlns:p="http://schemas.openxmlformats.org/presentationml/2006/main">
+  <p:cSld>
+    <p:spTree>
+      <p:nvGrpSpPr>
+        <p:cNvPr id="1" name=""/>
+        <p:cNvGrpSpPr/>
+        <p:nvPr/>
+      </p:nvGrpSpPr>
+      <p:grpSpPr>
+        <a:xfrm>
+          <a:off x="0" y="0"/>
+          <a:ext cx="0" cy="0"/>
+          <a:chOff x="0" y="0"/>
+          <a:chExt cx="0" cy="0"/>
+        </a:xfrm>
+      </p:grpSpPr>
+      <p:sp>
+        <p:nvSpPr>
+          <p:cNvPr id="2" name="Slide Image Placeholder 1"/>
+          <p:cNvSpPr>
+            <a:spLocks noGrp="1" noRot="1" noChangeAspect="1"/>
+          </p:cNvSpPr>
+          <p:nvPr>
+            <p:ph type="sldImg"/>
+          </p:nvPr>
+        </p:nvSpPr>
+        <p:spPr/>
+      </p:sp>
+      <p:sp>
+        <p:nvSpPr>
+          <p:cNvPr id="3" name="Notes Placeholder 2"/>
+          <p:cNvSpPr>
+            <a:spLocks noGrp="1"/>
+          </p:cNvSpPr>
+          <p:nvPr>
+            <p:ph type="body" idx="1"/>
+          </p:nvPr>
+        </p:nvSpPr>
+        <p:spPr/>
+        <p:txBody>
+          <a:bodyPr/>
+          <a:lstStyle/>
+          <a:p>
+            <a:r>
+              <a:rPr lang="en-US" dirty="0"/>
+              <a:t>[2:50–3:00] Every one of the 12 focus areas maps to features, code and tests in traceability.md — seven built, five partly built with the remaining stage named. Thank you — happy to break anything live.</a:t>
+            </a:r>
+            <a:endParaRPr lang="en-US" dirty="0"/>
+          </a:p>
+        </p:txBody>
+      </p:sp>
+      <p:sp>
+        <p:nvSpPr>
+          <p:cNvPr id="4" name="Slide Number Placeholder 3"/>
+          <p:cNvSpPr>
+            <a:spLocks noGrp="1"/>
+          </p:cNvSpPr>
+          <p:nvPr>
+            <p:ph type="sldNum" sz="quarter" idx="10"/>
+          </p:nvPr>
+        </p:nvSpPr>
+        <p:spPr/>
+        <p:txBody>
+          <a:bodyPr/>
+          <a:lstStyle/>
+          <a:p>
+            <a:fld id="{F7021451-1387-4CA6-816F-3879F97B5CBC}" type="slidenum">
+              <a:rPr lang="en-US"/>
+              <a:t>14</a:t>
             </a:fld>
             <a:endParaRPr lang="en-US"/>
           </a:p>
@@ -1130,7 +1219,7 @@
           <a:p>
             <a:r>
               <a:rPr lang="en-US" dirty="0"/>
-              <a:t>[0:40–0:55] Seat to relay to three independent data-centre cells to control. The relay at the centre is treated as hostile: it cannot read answers or forge a tick. The witness is on the roadmap, not built — we say so.</a:t>
+              <a:t>[0:40–0:55] Seat to relay to three independent data-centre cells to control. The relay at the centre is treated as hostile: it cannot read answers or forge a tick. The witness is built and cosigns the log, but in the demo it runs on the same host as control, so it is not yet independent custody — we say so.</a:t>
             </a:r>
             <a:endParaRPr lang="en-US" dirty="0"/>
           </a:p>
@@ -3041,7 +3130,7 @@
                 <a:ea typeface="Calibri" pitchFamily="34" charset="-122"/>
                 <a:cs typeface="Calibri" pitchFamily="34" charset="-120"/>
               </a:rPr>
-              <a:t>Not measured yet: 20k over real WAN, power loss, low-end seat CPU.</a:t>
+              <a:t>Not measured yet: real WAN, power loss, low-end seat CPU (20k was one Mac, loopback).</a:t>
             </a:r>
             <a:endParaRPr lang="en-US" sz="1500" dirty="0"/>
           </a:p>
@@ -3083,7 +3172,7 @@
                 <a:ea typeface="Calibri" pitchFamily="34" charset="-122"/>
                 <a:cs typeface="Calibri" pitchFamily="34" charset="-120"/>
               </a:rPr>
-              <a:t>Witness co-signing and pinned TLS are planned (Stage 7).</a:t>
+              <a:t>Witness is Built but on the same host as control, so not independent custody yet; pinned TLS is planned.</a:t>
             </a:r>
             <a:endParaRPr lang="en-US" sz="1500" dirty="0"/>
           </a:p>
@@ -3139,6 +3228,1589 @@
 <file path=ppt/slides/slide12.xml><?xml version="1.0" encoding="utf-8"?>
 <p:sld xmlns:a="http://schemas.openxmlformats.org/drawingml/2006/main" xmlns:r="http://schemas.openxmlformats.org/officeDocument/2006/relationships" xmlns:p="http://schemas.openxmlformats.org/presentationml/2006/main">
   <p:cSld name="Slide 12">
+    <p:bg>
+      <p:bgPr>
+        <a:solidFill>
+          <a:srgbClr val="FFFFFF"/>
+        </a:solidFill>
+      </p:bgPr>
+    </p:bg>
+    <p:spTree>
+      <p:nvGrpSpPr>
+        <p:cNvPr id="1" name=""/>
+        <p:cNvGrpSpPr/>
+        <p:nvPr/>
+      </p:nvGrpSpPr>
+      <p:grpSpPr>
+        <a:xfrm>
+          <a:off x="0" y="0"/>
+          <a:ext cx="0" cy="0"/>
+          <a:chOff x="0" y="0"/>
+          <a:chExt cx="0" cy="0"/>
+        </a:xfrm>
+      </p:grpSpPr>
+      <p:sp>
+        <p:nvSpPr>
+          <p:cNvPr id="2" name="Text 0"/>
+          <p:cNvSpPr txBox="1"/>
+          <p:nvPr/>
+        </p:nvSpPr>
+        <p:spPr>
+          <a:xfrm>
+            <a:off x="457200" y="320040"/>
+            <a:ext cx="8229600" cy="640080"/>
+          </a:xfrm>
+          <a:prstGeom prst="rect">
+            <a:avLst/>
+          </a:prstGeom>
+          <a:noFill/>
+          <a:ln/>
+        </p:spPr>
+        <p:txBody>
+          <a:bodyPr wrap="square" lIns="0" tIns="0" rIns="0" bIns="0" rtlCol="0" anchor="ctr"/>
+          <a:lstStyle/>
+          <a:p>
+            <a:pPr indent="0" marL="0">
+              <a:buNone/>
+            </a:pPr>
+            <a:r>
+              <a:rPr lang="en-US" sz="3000" b="1" dirty="0">
+                <a:solidFill>
+                  <a:srgbClr val="14213D"/>
+                </a:solidFill>
+                <a:latin typeface="Cambria" pitchFamily="34" charset="0"/>
+                <a:ea typeface="Cambria" pitchFamily="34" charset="-122"/>
+                <a:cs typeface="Cambria" pitchFamily="34" charset="-120"/>
+              </a:rPr>
+              <a:t>Measured numbers</a:t>
+            </a:r>
+            <a:endParaRPr lang="en-US" sz="3000" dirty="0"/>
+          </a:p>
+        </p:txBody>
+      </p:sp>
+      <p:graphicFrame>
+        <p:nvGraphicFramePr>
+          <p:cNvPr id="13" name="Table 0"/>
+          <p:cNvGraphicFramePr>
+            <a:graphicFrameLocks noGrp="1"/>
+          </p:cNvGraphicFramePr>
+          <p:nvPr>
+            <p:extLst>
+              <p:ext uri="{D42A27DB-BD31-4B8C-83A1-F6EECF244321}">
+                <p14:modId xmlns:p14="http://schemas.microsoft.com/office/powerpoint/2010/main" val="1579011935"/>
+              </p:ext>
+            </p:extLst>
+          </p:nvPr>
+        </p:nvGraphicFramePr>
+        <p:xfrm>
+          <a:off x="457200" y="1097280"/>
+          <a:ext cx="8229600" cy="914400"/>
+        </p:xfrm>
+        <a:graphic>
+          <a:graphicData uri="http://schemas.openxmlformats.org/drawingml/2006/table">
+            <a:tbl>
+              <a:tblPr/>
+              <a:tblGrid>
+                <a:gridCol w="3108960"/>
+                <a:gridCol w="3383280"/>
+                <a:gridCol w="1737360"/>
+              </a:tblGrid>
+              <a:tr h="411480">
+                <a:tc>
+                  <a:txBody>
+                    <a:bodyPr/>
+                    <a:lstStyle/>
+                    <a:p>
+                      <a:pPr indent="0" marL="0">
+                        <a:buNone/>
+                      </a:pPr>
+                      <a:r>
+                        <a:rPr lang="en-US" sz="1100" b="1" dirty="0">
+                          <a:solidFill>
+                            <a:srgbClr val="5B6475"/>
+                          </a:solidFill>
+                          <a:latin typeface="Calibri" pitchFamily="34" charset="0"/>
+                          <a:ea typeface="Calibri" pitchFamily="34" charset="-122"/>
+                          <a:cs typeface="Calibri" pitchFamily="34" charset="-120"/>
+                        </a:rPr>
+                        <a:t>Measure</a:t>
+                      </a:r>
+                      <a:endParaRPr lang="en-US" sz="1100" dirty="0">
+                        <a:latin typeface="Calibri" charset="0"/>
+                        <a:ea typeface="Calibri" charset="0"/>
+                        <a:cs typeface="Calibri" charset="0"/>
+                      </a:endParaRPr>
+                    </a:p>
+                  </a:txBody>
+                  <a:tcPr marL="91440" marR="91440" marT="45720" marB="45720">
+                    <a:lnL w="9525" cap="flat" cmpd="sng" algn="ctr">
+                      <a:solidFill>
+                        <a:srgbClr val="D5DAE3"/>
+                      </a:solidFill>
+                      <a:prstDash val="solid"/>
+                      <a:round/>
+                      <a:headEnd type="none" w="med" len="med"/>
+                      <a:tailEnd type="none" w="med" len="med"/>
+                    </a:lnL>
+                    <a:lnR w="9525" cap="flat" cmpd="sng" algn="ctr">
+                      <a:solidFill>
+                        <a:srgbClr val="D5DAE3"/>
+                      </a:solidFill>
+                      <a:prstDash val="solid"/>
+                      <a:round/>
+                      <a:headEnd type="none" w="med" len="med"/>
+                      <a:tailEnd type="none" w="med" len="med"/>
+                    </a:lnR>
+                    <a:lnT w="9525" cap="flat" cmpd="sng" algn="ctr">
+                      <a:solidFill>
+                        <a:srgbClr val="D5DAE3"/>
+                      </a:solidFill>
+                      <a:prstDash val="solid"/>
+                      <a:round/>
+                      <a:headEnd type="none" w="med" len="med"/>
+                      <a:tailEnd type="none" w="med" len="med"/>
+                    </a:lnT>
+                    <a:lnB w="9525" cap="flat" cmpd="sng" algn="ctr">
+                      <a:solidFill>
+                        <a:srgbClr val="D5DAE3"/>
+                      </a:solidFill>
+                      <a:prstDash val="solid"/>
+                      <a:round/>
+                      <a:headEnd type="none" w="med" len="med"/>
+                      <a:tailEnd type="none" w="med" len="med"/>
+                    </a:lnB>
+                    <a:solidFill>
+                      <a:srgbClr val="FFFFFF"/>
+                    </a:solidFill>
+                  </a:tcPr>
+                </a:tc>
+                <a:tc>
+                  <a:txBody>
+                    <a:bodyPr/>
+                    <a:lstStyle/>
+                    <a:p>
+                      <a:pPr indent="0" marL="0">
+                        <a:buNone/>
+                      </a:pPr>
+                      <a:r>
+                        <a:rPr lang="en-US" sz="1100" b="1" dirty="0">
+                          <a:solidFill>
+                            <a:srgbClr val="5B6475"/>
+                          </a:solidFill>
+                          <a:latin typeface="Calibri" pitchFamily="34" charset="0"/>
+                          <a:ea typeface="Calibri" pitchFamily="34" charset="-122"/>
+                          <a:cs typeface="Calibri" pitchFamily="34" charset="-120"/>
+                        </a:rPr>
+                        <a:t>Result</a:t>
+                      </a:r>
+                      <a:endParaRPr lang="en-US" sz="1100" dirty="0">
+                        <a:latin typeface="Calibri" charset="0"/>
+                        <a:ea typeface="Calibri" charset="0"/>
+                        <a:cs typeface="Calibri" charset="0"/>
+                      </a:endParaRPr>
+                    </a:p>
+                  </a:txBody>
+                  <a:tcPr marL="91440" marR="91440" marT="45720" marB="45720">
+                    <a:lnL w="9525" cap="flat" cmpd="sng" algn="ctr">
+                      <a:solidFill>
+                        <a:srgbClr val="D5DAE3"/>
+                      </a:solidFill>
+                      <a:prstDash val="solid"/>
+                      <a:round/>
+                      <a:headEnd type="none" w="med" len="med"/>
+                      <a:tailEnd type="none" w="med" len="med"/>
+                    </a:lnL>
+                    <a:lnR w="9525" cap="flat" cmpd="sng" algn="ctr">
+                      <a:solidFill>
+                        <a:srgbClr val="D5DAE3"/>
+                      </a:solidFill>
+                      <a:prstDash val="solid"/>
+                      <a:round/>
+                      <a:headEnd type="none" w="med" len="med"/>
+                      <a:tailEnd type="none" w="med" len="med"/>
+                    </a:lnR>
+                    <a:lnT w="9525" cap="flat" cmpd="sng" algn="ctr">
+                      <a:solidFill>
+                        <a:srgbClr val="D5DAE3"/>
+                      </a:solidFill>
+                      <a:prstDash val="solid"/>
+                      <a:round/>
+                      <a:headEnd type="none" w="med" len="med"/>
+                      <a:tailEnd type="none" w="med" len="med"/>
+                    </a:lnT>
+                    <a:lnB w="9525" cap="flat" cmpd="sng" algn="ctr">
+                      <a:solidFill>
+                        <a:srgbClr val="D5DAE3"/>
+                      </a:solidFill>
+                      <a:prstDash val="solid"/>
+                      <a:round/>
+                      <a:headEnd type="none" w="med" len="med"/>
+                      <a:tailEnd type="none" w="med" len="med"/>
+                    </a:lnB>
+                    <a:solidFill>
+                      <a:srgbClr val="FFFFFF"/>
+                    </a:solidFill>
+                  </a:tcPr>
+                </a:tc>
+                <a:tc>
+                  <a:txBody>
+                    <a:bodyPr/>
+                    <a:lstStyle/>
+                    <a:p>
+                      <a:pPr indent="0" marL="0">
+                        <a:buNone/>
+                      </a:pPr>
+                      <a:r>
+                        <a:rPr lang="en-US" sz="1100" b="1" dirty="0">
+                          <a:solidFill>
+                            <a:srgbClr val="5B6475"/>
+                          </a:solidFill>
+                          <a:latin typeface="Calibri" pitchFamily="34" charset="0"/>
+                          <a:ea typeface="Calibri" pitchFamily="34" charset="-122"/>
+                          <a:cs typeface="Calibri" pitchFamily="34" charset="-120"/>
+                        </a:rPr>
+                        <a:t>File (docs/evidence/)</a:t>
+                      </a:r>
+                      <a:endParaRPr lang="en-US" sz="1100" dirty="0">
+                        <a:latin typeface="Calibri" charset="0"/>
+                        <a:ea typeface="Calibri" charset="0"/>
+                        <a:cs typeface="Calibri" charset="0"/>
+                      </a:endParaRPr>
+                    </a:p>
+                  </a:txBody>
+                  <a:tcPr marL="91440" marR="91440" marT="45720" marB="45720">
+                    <a:lnL w="9525" cap="flat" cmpd="sng" algn="ctr">
+                      <a:solidFill>
+                        <a:srgbClr val="D5DAE3"/>
+                      </a:solidFill>
+                      <a:prstDash val="solid"/>
+                      <a:round/>
+                      <a:headEnd type="none" w="med" len="med"/>
+                      <a:tailEnd type="none" w="med" len="med"/>
+                    </a:lnL>
+                    <a:lnR w="9525" cap="flat" cmpd="sng" algn="ctr">
+                      <a:solidFill>
+                        <a:srgbClr val="D5DAE3"/>
+                      </a:solidFill>
+                      <a:prstDash val="solid"/>
+                      <a:round/>
+                      <a:headEnd type="none" w="med" len="med"/>
+                      <a:tailEnd type="none" w="med" len="med"/>
+                    </a:lnR>
+                    <a:lnT w="9525" cap="flat" cmpd="sng" algn="ctr">
+                      <a:solidFill>
+                        <a:srgbClr val="D5DAE3"/>
+                      </a:solidFill>
+                      <a:prstDash val="solid"/>
+                      <a:round/>
+                      <a:headEnd type="none" w="med" len="med"/>
+                      <a:tailEnd type="none" w="med" len="med"/>
+                    </a:lnT>
+                    <a:lnB w="9525" cap="flat" cmpd="sng" algn="ctr">
+                      <a:solidFill>
+                        <a:srgbClr val="D5DAE3"/>
+                      </a:solidFill>
+                      <a:prstDash val="solid"/>
+                      <a:round/>
+                      <a:headEnd type="none" w="med" len="med"/>
+                      <a:tailEnd type="none" w="med" len="med"/>
+                    </a:lnB>
+                    <a:solidFill>
+                      <a:srgbClr val="FFFFFF"/>
+                    </a:solidFill>
+                  </a:tcPr>
+                </a:tc>
+              </a:tr>
+              <a:tr h="411480">
+                <a:tc>
+                  <a:txBody>
+                    <a:bodyPr/>
+                    <a:lstStyle/>
+                    <a:p>
+                      <a:pPr indent="0" marL="0">
+                        <a:buNone/>
+                      </a:pPr>
+                      <a:r>
+                        <a:rPr lang="en-US" sz="1100" dirty="0">
+                          <a:solidFill>
+                            <a:srgbClr val="14213D"/>
+                          </a:solidFill>
+                          <a:latin typeface="Calibri" pitchFamily="34" charset="0"/>
+                          <a:ea typeface="Calibri" pitchFamily="34" charset="-122"/>
+                          <a:cs typeface="Calibri" pitchFamily="34" charset="-120"/>
+                        </a:rPr>
+                        <a:t>Ingest latency, relay to cell</a:t>
+                      </a:r>
+                      <a:endParaRPr lang="en-US" sz="1100" dirty="0">
+                        <a:latin typeface="Calibri" charset="0"/>
+                        <a:ea typeface="Calibri" charset="0"/>
+                        <a:cs typeface="Calibri" charset="0"/>
+                      </a:endParaRPr>
+                    </a:p>
+                  </a:txBody>
+                  <a:tcPr marL="91440" marR="91440" marT="45720" marB="45720">
+                    <a:lnL w="9525" cap="flat" cmpd="sng" algn="ctr">
+                      <a:solidFill>
+                        <a:srgbClr val="D5DAE3"/>
+                      </a:solidFill>
+                      <a:prstDash val="solid"/>
+                      <a:round/>
+                      <a:headEnd type="none" w="med" len="med"/>
+                      <a:tailEnd type="none" w="med" len="med"/>
+                    </a:lnL>
+                    <a:lnR w="9525" cap="flat" cmpd="sng" algn="ctr">
+                      <a:solidFill>
+                        <a:srgbClr val="D5DAE3"/>
+                      </a:solidFill>
+                      <a:prstDash val="solid"/>
+                      <a:round/>
+                      <a:headEnd type="none" w="med" len="med"/>
+                      <a:tailEnd type="none" w="med" len="med"/>
+                    </a:lnR>
+                    <a:lnT w="9525" cap="flat" cmpd="sng" algn="ctr">
+                      <a:solidFill>
+                        <a:srgbClr val="D5DAE3"/>
+                      </a:solidFill>
+                      <a:prstDash val="solid"/>
+                      <a:round/>
+                      <a:headEnd type="none" w="med" len="med"/>
+                      <a:tailEnd type="none" w="med" len="med"/>
+                    </a:lnT>
+                    <a:lnB w="9525" cap="flat" cmpd="sng" algn="ctr">
+                      <a:solidFill>
+                        <a:srgbClr val="D5DAE3"/>
+                      </a:solidFill>
+                      <a:prstDash val="solid"/>
+                      <a:round/>
+                      <a:headEnd type="none" w="med" len="med"/>
+                      <a:tailEnd type="none" w="med" len="med"/>
+                    </a:lnB>
+                    <a:solidFill>
+                      <a:srgbClr val="FFFFFF"/>
+                    </a:solidFill>
+                  </a:tcPr>
+                </a:tc>
+                <a:tc>
+                  <a:txBody>
+                    <a:bodyPr/>
+                    <a:lstStyle/>
+                    <a:p>
+                      <a:pPr indent="0" marL="0">
+                        <a:buNone/>
+                      </a:pPr>
+                      <a:r>
+                        <a:rPr lang="en-US" sz="1100" b="1" dirty="0">
+                          <a:solidFill>
+                            <a:srgbClr val="E07A1F"/>
+                          </a:solidFill>
+                          <a:latin typeface="Calibri" pitchFamily="34" charset="0"/>
+                          <a:ea typeface="Calibri" pitchFamily="34" charset="-122"/>
+                          <a:cs typeface="Calibri" pitchFamily="34" charset="-120"/>
+                        </a:rPr>
+                        <a:t>p50 44 ms · p99 168 ms</a:t>
+                      </a:r>
+                      <a:endParaRPr lang="en-US" sz="1100" dirty="0">
+                        <a:latin typeface="Calibri" charset="0"/>
+                        <a:ea typeface="Calibri" charset="0"/>
+                        <a:cs typeface="Calibri" charset="0"/>
+                      </a:endParaRPr>
+                    </a:p>
+                  </a:txBody>
+                  <a:tcPr marL="91440" marR="91440" marT="45720" marB="45720">
+                    <a:lnL w="9525" cap="flat" cmpd="sng" algn="ctr">
+                      <a:solidFill>
+                        <a:srgbClr val="D5DAE3"/>
+                      </a:solidFill>
+                      <a:prstDash val="solid"/>
+                      <a:round/>
+                      <a:headEnd type="none" w="med" len="med"/>
+                      <a:tailEnd type="none" w="med" len="med"/>
+                    </a:lnL>
+                    <a:lnR w="9525" cap="flat" cmpd="sng" algn="ctr">
+                      <a:solidFill>
+                        <a:srgbClr val="D5DAE3"/>
+                      </a:solidFill>
+                      <a:prstDash val="solid"/>
+                      <a:round/>
+                      <a:headEnd type="none" w="med" len="med"/>
+                      <a:tailEnd type="none" w="med" len="med"/>
+                    </a:lnR>
+                    <a:lnT w="9525" cap="flat" cmpd="sng" algn="ctr">
+                      <a:solidFill>
+                        <a:srgbClr val="D5DAE3"/>
+                      </a:solidFill>
+                      <a:prstDash val="solid"/>
+                      <a:round/>
+                      <a:headEnd type="none" w="med" len="med"/>
+                      <a:tailEnd type="none" w="med" len="med"/>
+                    </a:lnT>
+                    <a:lnB w="9525" cap="flat" cmpd="sng" algn="ctr">
+                      <a:solidFill>
+                        <a:srgbClr val="D5DAE3"/>
+                      </a:solidFill>
+                      <a:prstDash val="solid"/>
+                      <a:round/>
+                      <a:headEnd type="none" w="med" len="med"/>
+                      <a:tailEnd type="none" w="med" len="med"/>
+                    </a:lnB>
+                    <a:solidFill>
+                      <a:srgbClr val="FFFFFF"/>
+                    </a:solidFill>
+                  </a:tcPr>
+                </a:tc>
+                <a:tc>
+                  <a:txBody>
+                    <a:bodyPr/>
+                    <a:lstStyle/>
+                    <a:p>
+                      <a:pPr indent="0" marL="0">
+                        <a:buNone/>
+                      </a:pPr>
+                      <a:r>
+                        <a:rPr lang="en-US" sz="1100" dirty="0">
+                          <a:solidFill>
+                            <a:srgbClr val="14213D"/>
+                          </a:solidFill>
+                          <a:latin typeface="Calibri" pitchFamily="34" charset="0"/>
+                          <a:ea typeface="Calibri" pitchFamily="34" charset="-122"/>
+                          <a:cs typeface="Calibri" pitchFamily="34" charset="-120"/>
+                        </a:rPr>
+                        <a:t>stage7-load.txt</a:t>
+                      </a:r>
+                      <a:endParaRPr lang="en-US" sz="1100" dirty="0">
+                        <a:latin typeface="Calibri" charset="0"/>
+                        <a:ea typeface="Calibri" charset="0"/>
+                        <a:cs typeface="Calibri" charset="0"/>
+                      </a:endParaRPr>
+                    </a:p>
+                  </a:txBody>
+                  <a:tcPr marL="91440" marR="91440" marT="45720" marB="45720">
+                    <a:lnL w="9525" cap="flat" cmpd="sng" algn="ctr">
+                      <a:solidFill>
+                        <a:srgbClr val="D5DAE3"/>
+                      </a:solidFill>
+                      <a:prstDash val="solid"/>
+                      <a:round/>
+                      <a:headEnd type="none" w="med" len="med"/>
+                      <a:tailEnd type="none" w="med" len="med"/>
+                    </a:lnL>
+                    <a:lnR w="9525" cap="flat" cmpd="sng" algn="ctr">
+                      <a:solidFill>
+                        <a:srgbClr val="D5DAE3"/>
+                      </a:solidFill>
+                      <a:prstDash val="solid"/>
+                      <a:round/>
+                      <a:headEnd type="none" w="med" len="med"/>
+                      <a:tailEnd type="none" w="med" len="med"/>
+                    </a:lnR>
+                    <a:lnT w="9525" cap="flat" cmpd="sng" algn="ctr">
+                      <a:solidFill>
+                        <a:srgbClr val="D5DAE3"/>
+                      </a:solidFill>
+                      <a:prstDash val="solid"/>
+                      <a:round/>
+                      <a:headEnd type="none" w="med" len="med"/>
+                      <a:tailEnd type="none" w="med" len="med"/>
+                    </a:lnT>
+                    <a:lnB w="9525" cap="flat" cmpd="sng" algn="ctr">
+                      <a:solidFill>
+                        <a:srgbClr val="D5DAE3"/>
+                      </a:solidFill>
+                      <a:prstDash val="solid"/>
+                      <a:round/>
+                      <a:headEnd type="none" w="med" len="med"/>
+                      <a:tailEnd type="none" w="med" len="med"/>
+                    </a:lnB>
+                    <a:solidFill>
+                      <a:srgbClr val="FFFFFF"/>
+                    </a:solidFill>
+                  </a:tcPr>
+                </a:tc>
+              </a:tr>
+              <a:tr h="411480">
+                <a:tc>
+                  <a:txBody>
+                    <a:bodyPr/>
+                    <a:lstStyle/>
+                    <a:p>
+                      <a:pPr indent="0" marL="0">
+                        <a:buNone/>
+                      </a:pPr>
+                      <a:r>
+                        <a:rPr lang="en-US" sz="1100" dirty="0">
+                          <a:solidFill>
+                            <a:srgbClr val="14213D"/>
+                          </a:solidFill>
+                          <a:latin typeface="Calibri" pitchFamily="34" charset="0"/>
+                          <a:ea typeface="Calibri" pitchFamily="34" charset="-122"/>
+                          <a:cs typeface="Calibri" pitchFamily="34" charset="-120"/>
+                        </a:rPr>
+                        <a:t>Stored / rejected (20k cohort)</a:t>
+                      </a:r>
+                      <a:endParaRPr lang="en-US" sz="1100" dirty="0">
+                        <a:latin typeface="Calibri" charset="0"/>
+                        <a:ea typeface="Calibri" charset="0"/>
+                        <a:cs typeface="Calibri" charset="0"/>
+                      </a:endParaRPr>
+                    </a:p>
+                  </a:txBody>
+                  <a:tcPr marL="91440" marR="91440" marT="45720" marB="45720">
+                    <a:lnL w="9525" cap="flat" cmpd="sng" algn="ctr">
+                      <a:solidFill>
+                        <a:srgbClr val="D5DAE3"/>
+                      </a:solidFill>
+                      <a:prstDash val="solid"/>
+                      <a:round/>
+                      <a:headEnd type="none" w="med" len="med"/>
+                      <a:tailEnd type="none" w="med" len="med"/>
+                    </a:lnL>
+                    <a:lnR w="9525" cap="flat" cmpd="sng" algn="ctr">
+                      <a:solidFill>
+                        <a:srgbClr val="D5DAE3"/>
+                      </a:solidFill>
+                      <a:prstDash val="solid"/>
+                      <a:round/>
+                      <a:headEnd type="none" w="med" len="med"/>
+                      <a:tailEnd type="none" w="med" len="med"/>
+                    </a:lnR>
+                    <a:lnT w="9525" cap="flat" cmpd="sng" algn="ctr">
+                      <a:solidFill>
+                        <a:srgbClr val="D5DAE3"/>
+                      </a:solidFill>
+                      <a:prstDash val="solid"/>
+                      <a:round/>
+                      <a:headEnd type="none" w="med" len="med"/>
+                      <a:tailEnd type="none" w="med" len="med"/>
+                    </a:lnT>
+                    <a:lnB w="9525" cap="flat" cmpd="sng" algn="ctr">
+                      <a:solidFill>
+                        <a:srgbClr val="D5DAE3"/>
+                      </a:solidFill>
+                      <a:prstDash val="solid"/>
+                      <a:round/>
+                      <a:headEnd type="none" w="med" len="med"/>
+                      <a:tailEnd type="none" w="med" len="med"/>
+                    </a:lnB>
+                    <a:solidFill>
+                      <a:srgbClr val="FFFFFF"/>
+                    </a:solidFill>
+                  </a:tcPr>
+                </a:tc>
+                <a:tc>
+                  <a:txBody>
+                    <a:bodyPr/>
+                    <a:lstStyle/>
+                    <a:p>
+                      <a:pPr indent="0" marL="0">
+                        <a:buNone/>
+                      </a:pPr>
+                      <a:r>
+                        <a:rPr lang="en-US" sz="1100" b="1" dirty="0">
+                          <a:solidFill>
+                            <a:srgbClr val="E07A1F"/>
+                          </a:solidFill>
+                          <a:latin typeface="Calibri" pitchFamily="34" charset="0"/>
+                          <a:ea typeface="Calibri" pitchFamily="34" charset="-122"/>
+                          <a:cs typeface="Calibri" pitchFamily="34" charset="-120"/>
+                        </a:rPr>
+                        <a:t>227,882 entries · 0 rejected</a:t>
+                      </a:r>
+                      <a:endParaRPr lang="en-US" sz="1100" dirty="0">
+                        <a:latin typeface="Calibri" charset="0"/>
+                        <a:ea typeface="Calibri" charset="0"/>
+                        <a:cs typeface="Calibri" charset="0"/>
+                      </a:endParaRPr>
+                    </a:p>
+                  </a:txBody>
+                  <a:tcPr marL="91440" marR="91440" marT="45720" marB="45720">
+                    <a:lnL w="9525" cap="flat" cmpd="sng" algn="ctr">
+                      <a:solidFill>
+                        <a:srgbClr val="D5DAE3"/>
+                      </a:solidFill>
+                      <a:prstDash val="solid"/>
+                      <a:round/>
+                      <a:headEnd type="none" w="med" len="med"/>
+                      <a:tailEnd type="none" w="med" len="med"/>
+                    </a:lnL>
+                    <a:lnR w="9525" cap="flat" cmpd="sng" algn="ctr">
+                      <a:solidFill>
+                        <a:srgbClr val="D5DAE3"/>
+                      </a:solidFill>
+                      <a:prstDash val="solid"/>
+                      <a:round/>
+                      <a:headEnd type="none" w="med" len="med"/>
+                      <a:tailEnd type="none" w="med" len="med"/>
+                    </a:lnR>
+                    <a:lnT w="9525" cap="flat" cmpd="sng" algn="ctr">
+                      <a:solidFill>
+                        <a:srgbClr val="D5DAE3"/>
+                      </a:solidFill>
+                      <a:prstDash val="solid"/>
+                      <a:round/>
+                      <a:headEnd type="none" w="med" len="med"/>
+                      <a:tailEnd type="none" w="med" len="med"/>
+                    </a:lnT>
+                    <a:lnB w="9525" cap="flat" cmpd="sng" algn="ctr">
+                      <a:solidFill>
+                        <a:srgbClr val="D5DAE3"/>
+                      </a:solidFill>
+                      <a:prstDash val="solid"/>
+                      <a:round/>
+                      <a:headEnd type="none" w="med" len="med"/>
+                      <a:tailEnd type="none" w="med" len="med"/>
+                    </a:lnB>
+                    <a:solidFill>
+                      <a:srgbClr val="FFFFFF"/>
+                    </a:solidFill>
+                  </a:tcPr>
+                </a:tc>
+                <a:tc>
+                  <a:txBody>
+                    <a:bodyPr/>
+                    <a:lstStyle/>
+                    <a:p>
+                      <a:pPr indent="0" marL="0">
+                        <a:buNone/>
+                      </a:pPr>
+                      <a:r>
+                        <a:rPr lang="en-US" sz="1100" dirty="0">
+                          <a:solidFill>
+                            <a:srgbClr val="14213D"/>
+                          </a:solidFill>
+                          <a:latin typeface="Calibri" pitchFamily="34" charset="0"/>
+                          <a:ea typeface="Calibri" pitchFamily="34" charset="-122"/>
+                          <a:cs typeface="Calibri" pitchFamily="34" charset="-120"/>
+                        </a:rPr>
+                        <a:t>stage7-load.txt</a:t>
+                      </a:r>
+                      <a:endParaRPr lang="en-US" sz="1100" dirty="0">
+                        <a:latin typeface="Calibri" charset="0"/>
+                        <a:ea typeface="Calibri" charset="0"/>
+                        <a:cs typeface="Calibri" charset="0"/>
+                      </a:endParaRPr>
+                    </a:p>
+                  </a:txBody>
+                  <a:tcPr marL="91440" marR="91440" marT="45720" marB="45720">
+                    <a:lnL w="9525" cap="flat" cmpd="sng" algn="ctr">
+                      <a:solidFill>
+                        <a:srgbClr val="D5DAE3"/>
+                      </a:solidFill>
+                      <a:prstDash val="solid"/>
+                      <a:round/>
+                      <a:headEnd type="none" w="med" len="med"/>
+                      <a:tailEnd type="none" w="med" len="med"/>
+                    </a:lnL>
+                    <a:lnR w="9525" cap="flat" cmpd="sng" algn="ctr">
+                      <a:solidFill>
+                        <a:srgbClr val="D5DAE3"/>
+                      </a:solidFill>
+                      <a:prstDash val="solid"/>
+                      <a:round/>
+                      <a:headEnd type="none" w="med" len="med"/>
+                      <a:tailEnd type="none" w="med" len="med"/>
+                    </a:lnR>
+                    <a:lnT w="9525" cap="flat" cmpd="sng" algn="ctr">
+                      <a:solidFill>
+                        <a:srgbClr val="D5DAE3"/>
+                      </a:solidFill>
+                      <a:prstDash val="solid"/>
+                      <a:round/>
+                      <a:headEnd type="none" w="med" len="med"/>
+                      <a:tailEnd type="none" w="med" len="med"/>
+                    </a:lnT>
+                    <a:lnB w="9525" cap="flat" cmpd="sng" algn="ctr">
+                      <a:solidFill>
+                        <a:srgbClr val="D5DAE3"/>
+                      </a:solidFill>
+                      <a:prstDash val="solid"/>
+                      <a:round/>
+                      <a:headEnd type="none" w="med" len="med"/>
+                      <a:tailEnd type="none" w="med" len="med"/>
+                    </a:lnB>
+                    <a:solidFill>
+                      <a:srgbClr val="FFFFFF"/>
+                    </a:solidFill>
+                  </a:tcPr>
+                </a:tc>
+              </a:tr>
+              <a:tr h="411480">
+                <a:tc>
+                  <a:txBody>
+                    <a:bodyPr/>
+                    <a:lstStyle/>
+                    <a:p>
+                      <a:pPr indent="0" marL="0">
+                        <a:buNone/>
+                      </a:pPr>
+                      <a:r>
+                        <a:rPr lang="en-US" sz="1100" dirty="0">
+                          <a:solidFill>
+                            <a:srgbClr val="14213D"/>
+                          </a:solidFill>
+                          <a:latin typeface="Calibri" pitchFamily="34" charset="0"/>
+                          <a:ea typeface="Calibri" pitchFamily="34" charset="-122"/>
+                          <a:cs typeface="Calibri" pitchFamily="34" charset="-120"/>
+                        </a:rPr>
+                        <a:t>Candidates unlocked</a:t>
+                      </a:r>
+                      <a:endParaRPr lang="en-US" sz="1100" dirty="0">
+                        <a:latin typeface="Calibri" charset="0"/>
+                        <a:ea typeface="Calibri" charset="0"/>
+                        <a:cs typeface="Calibri" charset="0"/>
+                      </a:endParaRPr>
+                    </a:p>
+                  </a:txBody>
+                  <a:tcPr marL="91440" marR="91440" marT="45720" marB="45720">
+                    <a:lnL w="9525" cap="flat" cmpd="sng" algn="ctr">
+                      <a:solidFill>
+                        <a:srgbClr val="D5DAE3"/>
+                      </a:solidFill>
+                      <a:prstDash val="solid"/>
+                      <a:round/>
+                      <a:headEnd type="none" w="med" len="med"/>
+                      <a:tailEnd type="none" w="med" len="med"/>
+                    </a:lnL>
+                    <a:lnR w="9525" cap="flat" cmpd="sng" algn="ctr">
+                      <a:solidFill>
+                        <a:srgbClr val="D5DAE3"/>
+                      </a:solidFill>
+                      <a:prstDash val="solid"/>
+                      <a:round/>
+                      <a:headEnd type="none" w="med" len="med"/>
+                      <a:tailEnd type="none" w="med" len="med"/>
+                    </a:lnR>
+                    <a:lnT w="9525" cap="flat" cmpd="sng" algn="ctr">
+                      <a:solidFill>
+                        <a:srgbClr val="D5DAE3"/>
+                      </a:solidFill>
+                      <a:prstDash val="solid"/>
+                      <a:round/>
+                      <a:headEnd type="none" w="med" len="med"/>
+                      <a:tailEnd type="none" w="med" len="med"/>
+                    </a:lnT>
+                    <a:lnB w="9525" cap="flat" cmpd="sng" algn="ctr">
+                      <a:solidFill>
+                        <a:srgbClr val="D5DAE3"/>
+                      </a:solidFill>
+                      <a:prstDash val="solid"/>
+                      <a:round/>
+                      <a:headEnd type="none" w="med" len="med"/>
+                      <a:tailEnd type="none" w="med" len="med"/>
+                    </a:lnB>
+                    <a:solidFill>
+                      <a:srgbClr val="FFFFFF"/>
+                    </a:solidFill>
+                  </a:tcPr>
+                </a:tc>
+                <a:tc>
+                  <a:txBody>
+                    <a:bodyPr/>
+                    <a:lstStyle/>
+                    <a:p>
+                      <a:pPr indent="0" marL="0">
+                        <a:buNone/>
+                      </a:pPr>
+                      <a:r>
+                        <a:rPr lang="en-US" sz="1100" b="1" dirty="0">
+                          <a:solidFill>
+                            <a:srgbClr val="E07A1F"/>
+                          </a:solidFill>
+                          <a:latin typeface="Calibri" pitchFamily="34" charset="0"/>
+                          <a:ea typeface="Calibri" pitchFamily="34" charset="-122"/>
+                          <a:cs typeface="Calibri" pitchFamily="34" charset="-120"/>
+                        </a:rPr>
+                        <a:t>19,803 / 19,803</a:t>
+                      </a:r>
+                      <a:endParaRPr lang="en-US" sz="1100" dirty="0">
+                        <a:latin typeface="Calibri" charset="0"/>
+                        <a:ea typeface="Calibri" charset="0"/>
+                        <a:cs typeface="Calibri" charset="0"/>
+                      </a:endParaRPr>
+                    </a:p>
+                  </a:txBody>
+                  <a:tcPr marL="91440" marR="91440" marT="45720" marB="45720">
+                    <a:lnL w="9525" cap="flat" cmpd="sng" algn="ctr">
+                      <a:solidFill>
+                        <a:srgbClr val="D5DAE3"/>
+                      </a:solidFill>
+                      <a:prstDash val="solid"/>
+                      <a:round/>
+                      <a:headEnd type="none" w="med" len="med"/>
+                      <a:tailEnd type="none" w="med" len="med"/>
+                    </a:lnL>
+                    <a:lnR w="9525" cap="flat" cmpd="sng" algn="ctr">
+                      <a:solidFill>
+                        <a:srgbClr val="D5DAE3"/>
+                      </a:solidFill>
+                      <a:prstDash val="solid"/>
+                      <a:round/>
+                      <a:headEnd type="none" w="med" len="med"/>
+                      <a:tailEnd type="none" w="med" len="med"/>
+                    </a:lnR>
+                    <a:lnT w="9525" cap="flat" cmpd="sng" algn="ctr">
+                      <a:solidFill>
+                        <a:srgbClr val="D5DAE3"/>
+                      </a:solidFill>
+                      <a:prstDash val="solid"/>
+                      <a:round/>
+                      <a:headEnd type="none" w="med" len="med"/>
+                      <a:tailEnd type="none" w="med" len="med"/>
+                    </a:lnT>
+                    <a:lnB w="9525" cap="flat" cmpd="sng" algn="ctr">
+                      <a:solidFill>
+                        <a:srgbClr val="D5DAE3"/>
+                      </a:solidFill>
+                      <a:prstDash val="solid"/>
+                      <a:round/>
+                      <a:headEnd type="none" w="med" len="med"/>
+                      <a:tailEnd type="none" w="med" len="med"/>
+                    </a:lnB>
+                    <a:solidFill>
+                      <a:srgbClr val="FFFFFF"/>
+                    </a:solidFill>
+                  </a:tcPr>
+                </a:tc>
+                <a:tc>
+                  <a:txBody>
+                    <a:bodyPr/>
+                    <a:lstStyle/>
+                    <a:p>
+                      <a:pPr indent="0" marL="0">
+                        <a:buNone/>
+                      </a:pPr>
+                      <a:r>
+                        <a:rPr lang="en-US" sz="1100" dirty="0">
+                          <a:solidFill>
+                            <a:srgbClr val="14213D"/>
+                          </a:solidFill>
+                          <a:latin typeface="Calibri" pitchFamily="34" charset="0"/>
+                          <a:ea typeface="Calibri" pitchFamily="34" charset="-122"/>
+                          <a:cs typeface="Calibri" pitchFamily="34" charset="-120"/>
+                        </a:rPr>
+                        <a:t>stage7-load.txt</a:t>
+                      </a:r>
+                      <a:endParaRPr lang="en-US" sz="1100" dirty="0">
+                        <a:latin typeface="Calibri" charset="0"/>
+                        <a:ea typeface="Calibri" charset="0"/>
+                        <a:cs typeface="Calibri" charset="0"/>
+                      </a:endParaRPr>
+                    </a:p>
+                  </a:txBody>
+                  <a:tcPr marL="91440" marR="91440" marT="45720" marB="45720">
+                    <a:lnL w="9525" cap="flat" cmpd="sng" algn="ctr">
+                      <a:solidFill>
+                        <a:srgbClr val="D5DAE3"/>
+                      </a:solidFill>
+                      <a:prstDash val="solid"/>
+                      <a:round/>
+                      <a:headEnd type="none" w="med" len="med"/>
+                      <a:tailEnd type="none" w="med" len="med"/>
+                    </a:lnL>
+                    <a:lnR w="9525" cap="flat" cmpd="sng" algn="ctr">
+                      <a:solidFill>
+                        <a:srgbClr val="D5DAE3"/>
+                      </a:solidFill>
+                      <a:prstDash val="solid"/>
+                      <a:round/>
+                      <a:headEnd type="none" w="med" len="med"/>
+                      <a:tailEnd type="none" w="med" len="med"/>
+                    </a:lnR>
+                    <a:lnT w="9525" cap="flat" cmpd="sng" algn="ctr">
+                      <a:solidFill>
+                        <a:srgbClr val="D5DAE3"/>
+                      </a:solidFill>
+                      <a:prstDash val="solid"/>
+                      <a:round/>
+                      <a:headEnd type="none" w="med" len="med"/>
+                      <a:tailEnd type="none" w="med" len="med"/>
+                    </a:lnT>
+                    <a:lnB w="9525" cap="flat" cmpd="sng" algn="ctr">
+                      <a:solidFill>
+                        <a:srgbClr val="D5DAE3"/>
+                      </a:solidFill>
+                      <a:prstDash val="solid"/>
+                      <a:round/>
+                      <a:headEnd type="none" w="med" len="med"/>
+                      <a:tailEnd type="none" w="med" len="med"/>
+                    </a:lnB>
+                    <a:solidFill>
+                      <a:srgbClr val="FFFFFF"/>
+                    </a:solidFill>
+                  </a:tcPr>
+                </a:tc>
+              </a:tr>
+              <a:tr h="411480">
+                <a:tc>
+                  <a:txBody>
+                    <a:bodyPr/>
+                    <a:lstStyle/>
+                    <a:p>
+                      <a:pPr indent="0" marL="0">
+                        <a:buNone/>
+                      </a:pPr>
+                      <a:r>
+                        <a:rPr lang="en-US" sz="1100" dirty="0">
+                          <a:solidFill>
+                            <a:srgbClr val="14213D"/>
+                          </a:solidFill>
+                          <a:latin typeface="Calibri" pitchFamily="34" charset="0"/>
+                          <a:ea typeface="Calibri" pitchFamily="34" charset="-122"/>
+                          <a:cs typeface="Calibri" pitchFamily="34" charset="-120"/>
+                        </a:rPr>
+                        <a:t>Relay traffic per candidate-hour</a:t>
+                      </a:r>
+                      <a:endParaRPr lang="en-US" sz="1100" dirty="0">
+                        <a:latin typeface="Calibri" charset="0"/>
+                        <a:ea typeface="Calibri" charset="0"/>
+                        <a:cs typeface="Calibri" charset="0"/>
+                      </a:endParaRPr>
+                    </a:p>
+                  </a:txBody>
+                  <a:tcPr marL="91440" marR="91440" marT="45720" marB="45720">
+                    <a:lnL w="9525" cap="flat" cmpd="sng" algn="ctr">
+                      <a:solidFill>
+                        <a:srgbClr val="D5DAE3"/>
+                      </a:solidFill>
+                      <a:prstDash val="solid"/>
+                      <a:round/>
+                      <a:headEnd type="none" w="med" len="med"/>
+                      <a:tailEnd type="none" w="med" len="med"/>
+                    </a:lnL>
+                    <a:lnR w="9525" cap="flat" cmpd="sng" algn="ctr">
+                      <a:solidFill>
+                        <a:srgbClr val="D5DAE3"/>
+                      </a:solidFill>
+                      <a:prstDash val="solid"/>
+                      <a:round/>
+                      <a:headEnd type="none" w="med" len="med"/>
+                      <a:tailEnd type="none" w="med" len="med"/>
+                    </a:lnR>
+                    <a:lnT w="9525" cap="flat" cmpd="sng" algn="ctr">
+                      <a:solidFill>
+                        <a:srgbClr val="D5DAE3"/>
+                      </a:solidFill>
+                      <a:prstDash val="solid"/>
+                      <a:round/>
+                      <a:headEnd type="none" w="med" len="med"/>
+                      <a:tailEnd type="none" w="med" len="med"/>
+                    </a:lnT>
+                    <a:lnB w="9525" cap="flat" cmpd="sng" algn="ctr">
+                      <a:solidFill>
+                        <a:srgbClr val="D5DAE3"/>
+                      </a:solidFill>
+                      <a:prstDash val="solid"/>
+                      <a:round/>
+                      <a:headEnd type="none" w="med" len="med"/>
+                      <a:tailEnd type="none" w="med" len="med"/>
+                    </a:lnB>
+                    <a:solidFill>
+                      <a:srgbClr val="FFFFFF"/>
+                    </a:solidFill>
+                  </a:tcPr>
+                </a:tc>
+                <a:tc>
+                  <a:txBody>
+                    <a:bodyPr/>
+                    <a:lstStyle/>
+                    <a:p>
+                      <a:pPr indent="0" marL="0">
+                        <a:buNone/>
+                      </a:pPr>
+                      <a:r>
+                        <a:rPr lang="en-US" sz="1100" b="1" dirty="0">
+                          <a:solidFill>
+                            <a:srgbClr val="E07A1F"/>
+                          </a:solidFill>
+                          <a:latin typeface="Calibri" pitchFamily="34" charset="0"/>
+                          <a:ea typeface="Calibri" pitchFamily="34" charset="-122"/>
+                          <a:cs typeface="Calibri" pitchFamily="34" charset="-120"/>
+                        </a:rPr>
+                        <a:t>≈1.06 MB (60 s window extrapolated)</a:t>
+                      </a:r>
+                      <a:endParaRPr lang="en-US" sz="1100" dirty="0">
+                        <a:latin typeface="Calibri" charset="0"/>
+                        <a:ea typeface="Calibri" charset="0"/>
+                        <a:cs typeface="Calibri" charset="0"/>
+                      </a:endParaRPr>
+                    </a:p>
+                  </a:txBody>
+                  <a:tcPr marL="91440" marR="91440" marT="45720" marB="45720">
+                    <a:lnL w="9525" cap="flat" cmpd="sng" algn="ctr">
+                      <a:solidFill>
+                        <a:srgbClr val="D5DAE3"/>
+                      </a:solidFill>
+                      <a:prstDash val="solid"/>
+                      <a:round/>
+                      <a:headEnd type="none" w="med" len="med"/>
+                      <a:tailEnd type="none" w="med" len="med"/>
+                    </a:lnL>
+                    <a:lnR w="9525" cap="flat" cmpd="sng" algn="ctr">
+                      <a:solidFill>
+                        <a:srgbClr val="D5DAE3"/>
+                      </a:solidFill>
+                      <a:prstDash val="solid"/>
+                      <a:round/>
+                      <a:headEnd type="none" w="med" len="med"/>
+                      <a:tailEnd type="none" w="med" len="med"/>
+                    </a:lnR>
+                    <a:lnT w="9525" cap="flat" cmpd="sng" algn="ctr">
+                      <a:solidFill>
+                        <a:srgbClr val="D5DAE3"/>
+                      </a:solidFill>
+                      <a:prstDash val="solid"/>
+                      <a:round/>
+                      <a:headEnd type="none" w="med" len="med"/>
+                      <a:tailEnd type="none" w="med" len="med"/>
+                    </a:lnT>
+                    <a:lnB w="9525" cap="flat" cmpd="sng" algn="ctr">
+                      <a:solidFill>
+                        <a:srgbClr val="D5DAE3"/>
+                      </a:solidFill>
+                      <a:prstDash val="solid"/>
+                      <a:round/>
+                      <a:headEnd type="none" w="med" len="med"/>
+                      <a:tailEnd type="none" w="med" len="med"/>
+                    </a:lnB>
+                    <a:solidFill>
+                      <a:srgbClr val="FFFFFF"/>
+                    </a:solidFill>
+                  </a:tcPr>
+                </a:tc>
+                <a:tc>
+                  <a:txBody>
+                    <a:bodyPr/>
+                    <a:lstStyle/>
+                    <a:p>
+                      <a:pPr indent="0" marL="0">
+                        <a:buNone/>
+                      </a:pPr>
+                      <a:r>
+                        <a:rPr lang="en-US" sz="1100" dirty="0">
+                          <a:solidFill>
+                            <a:srgbClr val="14213D"/>
+                          </a:solidFill>
+                          <a:latin typeface="Calibri" pitchFamily="34" charset="0"/>
+                          <a:ea typeface="Calibri" pitchFamily="34" charset="-122"/>
+                          <a:cs typeface="Calibri" pitchFamily="34" charset="-120"/>
+                        </a:rPr>
+                        <a:t>stage7-load.txt</a:t>
+                      </a:r>
+                      <a:endParaRPr lang="en-US" sz="1100" dirty="0">
+                        <a:latin typeface="Calibri" charset="0"/>
+                        <a:ea typeface="Calibri" charset="0"/>
+                        <a:cs typeface="Calibri" charset="0"/>
+                      </a:endParaRPr>
+                    </a:p>
+                  </a:txBody>
+                  <a:tcPr marL="91440" marR="91440" marT="45720" marB="45720">
+                    <a:lnL w="9525" cap="flat" cmpd="sng" algn="ctr">
+                      <a:solidFill>
+                        <a:srgbClr val="D5DAE3"/>
+                      </a:solidFill>
+                      <a:prstDash val="solid"/>
+                      <a:round/>
+                      <a:headEnd type="none" w="med" len="med"/>
+                      <a:tailEnd type="none" w="med" len="med"/>
+                    </a:lnL>
+                    <a:lnR w="9525" cap="flat" cmpd="sng" algn="ctr">
+                      <a:solidFill>
+                        <a:srgbClr val="D5DAE3"/>
+                      </a:solidFill>
+                      <a:prstDash val="solid"/>
+                      <a:round/>
+                      <a:headEnd type="none" w="med" len="med"/>
+                      <a:tailEnd type="none" w="med" len="med"/>
+                    </a:lnR>
+                    <a:lnT w="9525" cap="flat" cmpd="sng" algn="ctr">
+                      <a:solidFill>
+                        <a:srgbClr val="D5DAE3"/>
+                      </a:solidFill>
+                      <a:prstDash val="solid"/>
+                      <a:round/>
+                      <a:headEnd type="none" w="med" len="med"/>
+                      <a:tailEnd type="none" w="med" len="med"/>
+                    </a:lnT>
+                    <a:lnB w="9525" cap="flat" cmpd="sng" algn="ctr">
+                      <a:solidFill>
+                        <a:srgbClr val="D5DAE3"/>
+                      </a:solidFill>
+                      <a:prstDash val="solid"/>
+                      <a:round/>
+                      <a:headEnd type="none" w="med" len="med"/>
+                      <a:tailEnd type="none" w="med" len="med"/>
+                    </a:lnB>
+                    <a:solidFill>
+                      <a:srgbClr val="FFFFFF"/>
+                    </a:solidFill>
+                  </a:tcPr>
+                </a:tc>
+              </a:tr>
+              <a:tr h="411480">
+                <a:tc>
+                  <a:txBody>
+                    <a:bodyPr/>
+                    <a:lstStyle/>
+                    <a:p>
+                      <a:pPr indent="0" marL="0">
+                        <a:buNone/>
+                      </a:pPr>
+                      <a:r>
+                        <a:rPr lang="en-US" sz="1100" dirty="0">
+                          <a:solidFill>
+                            <a:srgbClr val="14213D"/>
+                          </a:solidFill>
+                          <a:latin typeface="Calibri" pitchFamily="34" charset="0"/>
+                          <a:ea typeface="Calibri" pitchFamily="34" charset="-122"/>
+                          <a:cs typeface="Calibri" pitchFamily="34" charset="-120"/>
+                        </a:rPr>
+                        <a:t>Seat CPU / RSS (Node main process)</a:t>
+                      </a:r>
+                      <a:endParaRPr lang="en-US" sz="1100" dirty="0">
+                        <a:latin typeface="Calibri" charset="0"/>
+                        <a:ea typeface="Calibri" charset="0"/>
+                        <a:cs typeface="Calibri" charset="0"/>
+                      </a:endParaRPr>
+                    </a:p>
+                  </a:txBody>
+                  <a:tcPr marL="91440" marR="91440" marT="45720" marB="45720">
+                    <a:lnL w="9525" cap="flat" cmpd="sng" algn="ctr">
+                      <a:solidFill>
+                        <a:srgbClr val="D5DAE3"/>
+                      </a:solidFill>
+                      <a:prstDash val="solid"/>
+                      <a:round/>
+                      <a:headEnd type="none" w="med" len="med"/>
+                      <a:tailEnd type="none" w="med" len="med"/>
+                    </a:lnL>
+                    <a:lnR w="9525" cap="flat" cmpd="sng" algn="ctr">
+                      <a:solidFill>
+                        <a:srgbClr val="D5DAE3"/>
+                      </a:solidFill>
+                      <a:prstDash val="solid"/>
+                      <a:round/>
+                      <a:headEnd type="none" w="med" len="med"/>
+                      <a:tailEnd type="none" w="med" len="med"/>
+                    </a:lnR>
+                    <a:lnT w="9525" cap="flat" cmpd="sng" algn="ctr">
+                      <a:solidFill>
+                        <a:srgbClr val="D5DAE3"/>
+                      </a:solidFill>
+                      <a:prstDash val="solid"/>
+                      <a:round/>
+                      <a:headEnd type="none" w="med" len="med"/>
+                      <a:tailEnd type="none" w="med" len="med"/>
+                    </a:lnT>
+                    <a:lnB w="9525" cap="flat" cmpd="sng" algn="ctr">
+                      <a:solidFill>
+                        <a:srgbClr val="D5DAE3"/>
+                      </a:solidFill>
+                      <a:prstDash val="solid"/>
+                      <a:round/>
+                      <a:headEnd type="none" w="med" len="med"/>
+                      <a:tailEnd type="none" w="med" len="med"/>
+                    </a:lnB>
+                    <a:solidFill>
+                      <a:srgbClr val="FFFFFF"/>
+                    </a:solidFill>
+                  </a:tcPr>
+                </a:tc>
+                <a:tc>
+                  <a:txBody>
+                    <a:bodyPr/>
+                    <a:lstStyle/>
+                    <a:p>
+                      <a:pPr indent="0" marL="0">
+                        <a:buNone/>
+                      </a:pPr>
+                      <a:r>
+                        <a:rPr lang="en-US" sz="1100" b="1" dirty="0">
+                          <a:solidFill>
+                            <a:srgbClr val="E07A1F"/>
+                          </a:solidFill>
+                          <a:latin typeface="Calibri" pitchFamily="34" charset="0"/>
+                          <a:ea typeface="Calibri" pitchFamily="34" charset="-122"/>
+                          <a:cs typeface="Calibri" pitchFamily="34" charset="-120"/>
+                        </a:rPr>
+                        <a:t>2.3% median · 166 MiB</a:t>
+                      </a:r>
+                      <a:endParaRPr lang="en-US" sz="1100" dirty="0">
+                        <a:latin typeface="Calibri" charset="0"/>
+                        <a:ea typeface="Calibri" charset="0"/>
+                        <a:cs typeface="Calibri" charset="0"/>
+                      </a:endParaRPr>
+                    </a:p>
+                  </a:txBody>
+                  <a:tcPr marL="91440" marR="91440" marT="45720" marB="45720">
+                    <a:lnL w="9525" cap="flat" cmpd="sng" algn="ctr">
+                      <a:solidFill>
+                        <a:srgbClr val="D5DAE3"/>
+                      </a:solidFill>
+                      <a:prstDash val="solid"/>
+                      <a:round/>
+                      <a:headEnd type="none" w="med" len="med"/>
+                      <a:tailEnd type="none" w="med" len="med"/>
+                    </a:lnL>
+                    <a:lnR w="9525" cap="flat" cmpd="sng" algn="ctr">
+                      <a:solidFill>
+                        <a:srgbClr val="D5DAE3"/>
+                      </a:solidFill>
+                      <a:prstDash val="solid"/>
+                      <a:round/>
+                      <a:headEnd type="none" w="med" len="med"/>
+                      <a:tailEnd type="none" w="med" len="med"/>
+                    </a:lnR>
+                    <a:lnT w="9525" cap="flat" cmpd="sng" algn="ctr">
+                      <a:solidFill>
+                        <a:srgbClr val="D5DAE3"/>
+                      </a:solidFill>
+                      <a:prstDash val="solid"/>
+                      <a:round/>
+                      <a:headEnd type="none" w="med" len="med"/>
+                      <a:tailEnd type="none" w="med" len="med"/>
+                    </a:lnT>
+                    <a:lnB w="9525" cap="flat" cmpd="sng" algn="ctr">
+                      <a:solidFill>
+                        <a:srgbClr val="D5DAE3"/>
+                      </a:solidFill>
+                      <a:prstDash val="solid"/>
+                      <a:round/>
+                      <a:headEnd type="none" w="med" len="med"/>
+                      <a:tailEnd type="none" w="med" len="med"/>
+                    </a:lnB>
+                    <a:solidFill>
+                      <a:srgbClr val="FFFFFF"/>
+                    </a:solidFill>
+                  </a:tcPr>
+                </a:tc>
+                <a:tc>
+                  <a:txBody>
+                    <a:bodyPr/>
+                    <a:lstStyle/>
+                    <a:p>
+                      <a:pPr indent="0" marL="0">
+                        <a:buNone/>
+                      </a:pPr>
+                      <a:r>
+                        <a:rPr lang="en-US" sz="1100" dirty="0">
+                          <a:solidFill>
+                            <a:srgbClr val="14213D"/>
+                          </a:solidFill>
+                          <a:latin typeface="Calibri" pitchFamily="34" charset="0"/>
+                          <a:ea typeface="Calibri" pitchFamily="34" charset="-122"/>
+                          <a:cs typeface="Calibri" pitchFamily="34" charset="-120"/>
+                        </a:rPr>
+                        <a:t>stage7-load.txt</a:t>
+                      </a:r>
+                      <a:endParaRPr lang="en-US" sz="1100" dirty="0">
+                        <a:latin typeface="Calibri" charset="0"/>
+                        <a:ea typeface="Calibri" charset="0"/>
+                        <a:cs typeface="Calibri" charset="0"/>
+                      </a:endParaRPr>
+                    </a:p>
+                  </a:txBody>
+                  <a:tcPr marL="91440" marR="91440" marT="45720" marB="45720">
+                    <a:lnL w="9525" cap="flat" cmpd="sng" algn="ctr">
+                      <a:solidFill>
+                        <a:srgbClr val="D5DAE3"/>
+                      </a:solidFill>
+                      <a:prstDash val="solid"/>
+                      <a:round/>
+                      <a:headEnd type="none" w="med" len="med"/>
+                      <a:tailEnd type="none" w="med" len="med"/>
+                    </a:lnL>
+                    <a:lnR w="9525" cap="flat" cmpd="sng" algn="ctr">
+                      <a:solidFill>
+                        <a:srgbClr val="D5DAE3"/>
+                      </a:solidFill>
+                      <a:prstDash val="solid"/>
+                      <a:round/>
+                      <a:headEnd type="none" w="med" len="med"/>
+                      <a:tailEnd type="none" w="med" len="med"/>
+                    </a:lnR>
+                    <a:lnT w="9525" cap="flat" cmpd="sng" algn="ctr">
+                      <a:solidFill>
+                        <a:srgbClr val="D5DAE3"/>
+                      </a:solidFill>
+                      <a:prstDash val="solid"/>
+                      <a:round/>
+                      <a:headEnd type="none" w="med" len="med"/>
+                      <a:tailEnd type="none" w="med" len="med"/>
+                    </a:lnT>
+                    <a:lnB w="9525" cap="flat" cmpd="sng" algn="ctr">
+                      <a:solidFill>
+                        <a:srgbClr val="D5DAE3"/>
+                      </a:solidFill>
+                      <a:prstDash val="solid"/>
+                      <a:round/>
+                      <a:headEnd type="none" w="med" len="med"/>
+                      <a:tailEnd type="none" w="med" len="med"/>
+                    </a:lnB>
+                    <a:solidFill>
+                      <a:srgbClr val="FFFFFF"/>
+                    </a:solidFill>
+                  </a:tcPr>
+                </a:tc>
+              </a:tr>
+              <a:tr h="411480">
+                <a:tc>
+                  <a:txBody>
+                    <a:bodyPr/>
+                    <a:lstStyle/>
+                    <a:p>
+                      <a:pPr indent="0" marL="0">
+                        <a:buNone/>
+                      </a:pPr>
+                      <a:r>
+                        <a:rPr lang="en-US" sz="1100" dirty="0">
+                          <a:solidFill>
+                            <a:srgbClr val="14213D"/>
+                          </a:solidFill>
+                          <a:latin typeface="Calibri" pitchFamily="34" charset="0"/>
+                          <a:ea typeface="Calibri" pitchFamily="34" charset="-122"/>
+                          <a:cs typeface="Calibri" pitchFamily="34" charset="-120"/>
+                        </a:rPr>
+                        <a:t>Chaos drill, 20 runs</a:t>
+                      </a:r>
+                      <a:endParaRPr lang="en-US" sz="1100" dirty="0">
+                        <a:latin typeface="Calibri" charset="0"/>
+                        <a:ea typeface="Calibri" charset="0"/>
+                        <a:cs typeface="Calibri" charset="0"/>
+                      </a:endParaRPr>
+                    </a:p>
+                  </a:txBody>
+                  <a:tcPr marL="91440" marR="91440" marT="45720" marB="45720">
+                    <a:lnL w="9525" cap="flat" cmpd="sng" algn="ctr">
+                      <a:solidFill>
+                        <a:srgbClr val="D5DAE3"/>
+                      </a:solidFill>
+                      <a:prstDash val="solid"/>
+                      <a:round/>
+                      <a:headEnd type="none" w="med" len="med"/>
+                      <a:tailEnd type="none" w="med" len="med"/>
+                    </a:lnL>
+                    <a:lnR w="9525" cap="flat" cmpd="sng" algn="ctr">
+                      <a:solidFill>
+                        <a:srgbClr val="D5DAE3"/>
+                      </a:solidFill>
+                      <a:prstDash val="solid"/>
+                      <a:round/>
+                      <a:headEnd type="none" w="med" len="med"/>
+                      <a:tailEnd type="none" w="med" len="med"/>
+                    </a:lnR>
+                    <a:lnT w="9525" cap="flat" cmpd="sng" algn="ctr">
+                      <a:solidFill>
+                        <a:srgbClr val="D5DAE3"/>
+                      </a:solidFill>
+                      <a:prstDash val="solid"/>
+                      <a:round/>
+                      <a:headEnd type="none" w="med" len="med"/>
+                      <a:tailEnd type="none" w="med" len="med"/>
+                    </a:lnT>
+                    <a:lnB w="9525" cap="flat" cmpd="sng" algn="ctr">
+                      <a:solidFill>
+                        <a:srgbClr val="D5DAE3"/>
+                      </a:solidFill>
+                      <a:prstDash val="solid"/>
+                      <a:round/>
+                      <a:headEnd type="none" w="med" len="med"/>
+                      <a:tailEnd type="none" w="med" len="med"/>
+                    </a:lnB>
+                    <a:solidFill>
+                      <a:srgbClr val="FFFFFF"/>
+                    </a:solidFill>
+                  </a:tcPr>
+                </a:tc>
+                <a:tc>
+                  <a:txBody>
+                    <a:bodyPr/>
+                    <a:lstStyle/>
+                    <a:p>
+                      <a:pPr indent="0" marL="0">
+                        <a:buNone/>
+                      </a:pPr>
+                      <a:r>
+                        <a:rPr lang="en-US" sz="1100" b="1" dirty="0">
+                          <a:solidFill>
+                            <a:srgbClr val="E07A1F"/>
+                          </a:solidFill>
+                          <a:latin typeface="Calibri" pitchFamily="34" charset="0"/>
+                          <a:ea typeface="Calibri" pitchFamily="34" charset="-122"/>
+                          <a:cs typeface="Calibri" pitchFamily="34" charset="-120"/>
+                        </a:rPr>
+                        <a:t>0 of 16,000 answers lost · RTO medians 0.96–1.23 s</a:t>
+                      </a:r>
+                      <a:endParaRPr lang="en-US" sz="1100" dirty="0">
+                        <a:latin typeface="Calibri" charset="0"/>
+                        <a:ea typeface="Calibri" charset="0"/>
+                        <a:cs typeface="Calibri" charset="0"/>
+                      </a:endParaRPr>
+                    </a:p>
+                  </a:txBody>
+                  <a:tcPr marL="91440" marR="91440" marT="45720" marB="45720">
+                    <a:lnL w="9525" cap="flat" cmpd="sng" algn="ctr">
+                      <a:solidFill>
+                        <a:srgbClr val="D5DAE3"/>
+                      </a:solidFill>
+                      <a:prstDash val="solid"/>
+                      <a:round/>
+                      <a:headEnd type="none" w="med" len="med"/>
+                      <a:tailEnd type="none" w="med" len="med"/>
+                    </a:lnL>
+                    <a:lnR w="9525" cap="flat" cmpd="sng" algn="ctr">
+                      <a:solidFill>
+                        <a:srgbClr val="D5DAE3"/>
+                      </a:solidFill>
+                      <a:prstDash val="solid"/>
+                      <a:round/>
+                      <a:headEnd type="none" w="med" len="med"/>
+                      <a:tailEnd type="none" w="med" len="med"/>
+                    </a:lnR>
+                    <a:lnT w="9525" cap="flat" cmpd="sng" algn="ctr">
+                      <a:solidFill>
+                        <a:srgbClr val="D5DAE3"/>
+                      </a:solidFill>
+                      <a:prstDash val="solid"/>
+                      <a:round/>
+                      <a:headEnd type="none" w="med" len="med"/>
+                      <a:tailEnd type="none" w="med" len="med"/>
+                    </a:lnT>
+                    <a:lnB w="9525" cap="flat" cmpd="sng" algn="ctr">
+                      <a:solidFill>
+                        <a:srgbClr val="D5DAE3"/>
+                      </a:solidFill>
+                      <a:prstDash val="solid"/>
+                      <a:round/>
+                      <a:headEnd type="none" w="med" len="med"/>
+                      <a:tailEnd type="none" w="med" len="med"/>
+                    </a:lnB>
+                    <a:solidFill>
+                      <a:srgbClr val="FFFFFF"/>
+                    </a:solidFill>
+                  </a:tcPr>
+                </a:tc>
+                <a:tc>
+                  <a:txBody>
+                    <a:bodyPr/>
+                    <a:lstStyle/>
+                    <a:p>
+                      <a:pPr indent="0" marL="0">
+                        <a:buNone/>
+                      </a:pPr>
+                      <a:r>
+                        <a:rPr lang="en-US" sz="1100" dirty="0">
+                          <a:solidFill>
+                            <a:srgbClr val="14213D"/>
+                          </a:solidFill>
+                          <a:latin typeface="Calibri" pitchFamily="34" charset="0"/>
+                          <a:ea typeface="Calibri" pitchFamily="34" charset="-122"/>
+                          <a:cs typeface="Calibri" pitchFamily="34" charset="-120"/>
+                        </a:rPr>
+                        <a:t>stage8-chaos.txt</a:t>
+                      </a:r>
+                      <a:endParaRPr lang="en-US" sz="1100" dirty="0">
+                        <a:latin typeface="Calibri" charset="0"/>
+                        <a:ea typeface="Calibri" charset="0"/>
+                        <a:cs typeface="Calibri" charset="0"/>
+                      </a:endParaRPr>
+                    </a:p>
+                  </a:txBody>
+                  <a:tcPr marL="91440" marR="91440" marT="45720" marB="45720">
+                    <a:lnL w="9525" cap="flat" cmpd="sng" algn="ctr">
+                      <a:solidFill>
+                        <a:srgbClr val="D5DAE3"/>
+                      </a:solidFill>
+                      <a:prstDash val="solid"/>
+                      <a:round/>
+                      <a:headEnd type="none" w="med" len="med"/>
+                      <a:tailEnd type="none" w="med" len="med"/>
+                    </a:lnL>
+                    <a:lnR w="9525" cap="flat" cmpd="sng" algn="ctr">
+                      <a:solidFill>
+                        <a:srgbClr val="D5DAE3"/>
+                      </a:solidFill>
+                      <a:prstDash val="solid"/>
+                      <a:round/>
+                      <a:headEnd type="none" w="med" len="med"/>
+                      <a:tailEnd type="none" w="med" len="med"/>
+                    </a:lnR>
+                    <a:lnT w="9525" cap="flat" cmpd="sng" algn="ctr">
+                      <a:solidFill>
+                        <a:srgbClr val="D5DAE3"/>
+                      </a:solidFill>
+                      <a:prstDash val="solid"/>
+                      <a:round/>
+                      <a:headEnd type="none" w="med" len="med"/>
+                      <a:tailEnd type="none" w="med" len="med"/>
+                    </a:lnT>
+                    <a:lnB w="9525" cap="flat" cmpd="sng" algn="ctr">
+                      <a:solidFill>
+                        <a:srgbClr val="D5DAE3"/>
+                      </a:solidFill>
+                      <a:prstDash val="solid"/>
+                      <a:round/>
+                      <a:headEnd type="none" w="med" len="med"/>
+                      <a:tailEnd type="none" w="med" len="med"/>
+                    </a:lnB>
+                    <a:solidFill>
+                      <a:srgbClr val="FFFFFF"/>
+                    </a:solidFill>
+                  </a:tcPr>
+                </a:tc>
+              </a:tr>
+            </a:tbl>
+          </a:graphicData>
+        </a:graphic>
+      </p:graphicFrame>
+      <p:sp>
+        <p:nvSpPr>
+          <p:cNvPr id="4" name="Text 1"/>
+          <p:cNvSpPr txBox="1"/>
+          <p:nvPr/>
+        </p:nvSpPr>
+        <p:spPr>
+          <a:xfrm>
+            <a:off x="457200" y="4754880"/>
+            <a:ext cx="8229600" cy="256032"/>
+          </a:xfrm>
+          <a:prstGeom prst="rect">
+            <a:avLst/>
+          </a:prstGeom>
+          <a:noFill/>
+          <a:ln/>
+        </p:spPr>
+        <p:txBody>
+          <a:bodyPr wrap="square" lIns="0" tIns="0" rIns="0" bIns="0" rtlCol="0" anchor="ctr"/>
+          <a:lstStyle/>
+          <a:p>
+            <a:pPr indent="0" marL="0">
+              <a:buNone/>
+            </a:pPr>
+            <a:r>
+              <a:rPr lang="en-US" sz="900" i="1" dirty="0">
+                <a:solidFill>
+                  <a:srgbClr val="5B6475"/>
+                </a:solidFill>
+                <a:latin typeface="Calibri" pitchFamily="34" charset="0"/>
+                <a:ea typeface="Calibri" pitchFamily="34" charset="-122"/>
+                <a:cs typeface="Calibri" pitchFamily="34" charset="-120"/>
+              </a:rPr>
+              <a:t>One Apple M5 Mac, 3 real cells on loopback, 99 simulated centres, synthetic cohort. Seat figures cover the Node main process only; not real WAN.</a:t>
+            </a:r>
+            <a:endParaRPr lang="en-US" sz="900" dirty="0"/>
+          </a:p>
+        </p:txBody>
+      </p:sp>
+    </p:spTree>
+  </p:cSld>
+  <p:clrMapOvr>
+    <a:masterClrMapping/>
+  </p:clrMapOvr>
+</p:sld>
+</file>
+
+<file path=ppt/slides/slide13.xml><?xml version="1.0" encoding="utf-8"?>
+<p:sld xmlns:a="http://schemas.openxmlformats.org/drawingml/2006/main" xmlns:r="http://schemas.openxmlformats.org/officeDocument/2006/relationships" xmlns:p="http://schemas.openxmlformats.org/presentationml/2006/main">
+  <p:cSld name="Slide 13">
     <p:bg>
       <p:bgPr>
         <a:solidFill>
@@ -3352,9 +5024,9 @@
 </p:sld>
 </file>
 
-<file path=ppt/slides/slide13.xml><?xml version="1.0" encoding="utf-8"?>
+<file path=ppt/slides/slide14.xml><?xml version="1.0" encoding="utf-8"?>
 <p:sld xmlns:a="http://schemas.openxmlformats.org/drawingml/2006/main" xmlns:r="http://schemas.openxmlformats.org/officeDocument/2006/relationships" xmlns:p="http://schemas.openxmlformats.org/presentationml/2006/main">
-  <p:cSld name="Slide 13">
+  <p:cSld name="Slide 14">
     <p:bg>
       <p:bgPr>
         <a:solidFill>
@@ -3417,7 +5089,7 @@
       </p:sp>
       <p:graphicFrame>
         <p:nvGraphicFramePr>
-          <p:cNvPr id="14" name="Table 0"/>
+          <p:cNvPr id="15" name="Table 0"/>
           <p:cNvGraphicFramePr>
             <a:graphicFrameLocks noGrp="1"/>
           </p:cNvGraphicFramePr>
@@ -5124,7 +6796,7 @@
                 <a:ea typeface="Calibri" pitchFamily="34" charset="-122"/>
                 <a:cs typeface="Calibri" pitchFamily="34" charset="-120"/>
               </a:rPr>
-              <a:t>Source: docs/traceability.md summary table. * without the witness (Stage 7). "Partly" rows name their remaining stage there.</a:t>
+              <a:t>Source: docs/traceability.md summary table. * witness Built, but on the same host as control (not independent custody). "Partly" rows name their remaining stage there.</a:t>
             </a:r>
             <a:endParaRPr lang="en-US" sz="900" dirty="0"/>
           </a:p>
@@ -6704,7 +8376,7 @@
                 <a:ea typeface="Calibri" pitchFamily="34" charset="-122"/>
                 <a:cs typeface="Calibri" pitchFamily="34" charset="-120"/>
               </a:rPr>
-              <a:t>co-signs the log (planned, Stage 7)</a:t>
+              <a:t>co-signs the log (Built; same host as control)</a:t>
             </a:r>
             <a:endParaRPr lang="en-US" sz="1200" dirty="0"/>
           </a:p>
@@ -7678,7 +9350,7 @@
                 <a:ea typeface="Calibri" pitchFamily="34" charset="-122"/>
                 <a:cs typeface="Calibri" pitchFamily="34" charset="-120"/>
               </a:rPr>
-              <a:t>Evidence: claims-ledger P1–P4, D16; docs/evidence/stage4-act3.txt. SYNC_LAG is proven on our chaos drill only, not real WAN data.</a:t>
+              <a:t>Evidence: docs/evidence/stage8-act2.txt (PASS, 308 candidates, 7 centres); claims-ledger P1–P4, D16. SYNC_LAG is proven on our chaos drill only, not real WAN data.</a:t>
             </a:r>
             <a:endParaRPr lang="en-US" sz="900" dirty="0"/>
           </a:p>

</xml_diff>

<commit_message>
docs: submission wording pass (platform, limits as roadmap, no internal jargon); rebuild deck
</commit_message>
<xml_diff>
--- a/docs/deck/saakshi.pptx
+++ b/docs/deck/saakshi.pptx
@@ -691,7 +691,7 @@
           <a:p>
             <a:r>
               <a:rPr lang="en-US" dirty="0"/>
-              <a:t>[2:30–2:40] We lead with our limits because a trust system that oversells is worthless. Everything on this slide is written in our threat model and claims ledger.</a:t>
+              <a:t>[2:30–2:40] We state our limits and our roadmap plainly because a trust system that oversells is worthless. Everything on this slide is written in our threat model and claims ledger.</a:t>
             </a:r>
             <a:endParaRPr lang="en-US" dirty="0"/>
           </a:p>
@@ -867,7 +867,7 @@
           <a:p>
             <a:r>
               <a:rPr lang="en-US" dirty="0"/>
-              <a:t>[2:40–2:50] Close. We are not asking NTA to buy our software; we are offering a protocol and a conformance kit to write into the RFP. Cost per candidate is a Stage 7 measurement — we will not quote a number we have not measured.</a:t>
+              <a:t>[2:40–2:50] Close. We are not asking NTA to buy our software; we are offering a protocol and a conformance kit to write into the RFP. We quote only numbers we have measured, so no cost per candidate here.</a:t>
             </a:r>
             <a:endParaRPr lang="en-US" dirty="0"/>
           </a:p>
@@ -1219,7 +1219,7 @@
           <a:p>
             <a:r>
               <a:rPr lang="en-US" dirty="0"/>
-              <a:t>[0:40–0:55] Seat to relay to three independent data-centre cells to control. The relay at the centre is treated as hostile: it cannot read answers or forge a tick. The witness is built and cosigns the log, but in the demo it runs on the same host as control, so it is not yet independent custody — we say so.</a:t>
+              <a:t>[0:40–0:55] Seat to relay to three independent data-centre cells to control. The relay at the centre is treated as hostile: it cannot read answers or forge a tick. The witness is built and cosigns the log; in the demo it runs on the same host as control, and independent custody is on the roadmap.</a:t>
             </a:r>
             <a:endParaRPr lang="en-US" dirty="0"/>
           </a:p>
@@ -1307,7 +1307,7 @@
           <a:p>
             <a:r>
               <a:rPr lang="en-US" dirty="0"/>
-              <a:t>[0:55–1:10] Act 1. The gate blocks by name, names the tool, and turns green once closed. Accessibility tools are allowed. Face presence runs on the device — no video, no recognition — and every flag goes to a human. Honest limit: name matching only.</a:t>
+              <a:t>[0:55–1:10] Act 1. The gate blocks by name, names the tool, and turns green once closed. Face presence runs on the device — no video, no recognition — and every flag goes to a human. Detection is by process name.</a:t>
             </a:r>
             <a:endParaRPr lang="en-US" dirty="0"/>
           </a:p>
@@ -3024,7 +3024,7 @@
                 <a:ea typeface="Cambria" pitchFamily="34" charset="-122"/>
                 <a:cs typeface="Cambria" pitchFamily="34" charset="-120"/>
               </a:rPr>
-              <a:t>What we do not claim</a:t>
+              <a:t>Limits and roadmap</a:t>
             </a:r>
             <a:endParaRPr lang="en-US" sz="3000" dirty="0"/>
           </a:p>
@@ -3067,7 +3067,7 @@
                 <a:ea typeface="Calibri" pitchFamily="34" charset="-122"/>
                 <a:cs typeface="Calibri" pitchFamily="34" charset="-120"/>
               </a:rPr>
-              <a:t>Not cheat-proof: deterrence plus detection; records are tamper-evident.</a:t>
+              <a:t>Deterrence plus detection, not cheat-proof; records are tamper-evident.</a:t>
             </a:r>
             <a:endParaRPr lang="en-US" sz="1500" dirty="0"/>
           </a:p>
@@ -3088,7 +3088,7 @@
                 <a:ea typeface="Calibri" pitchFamily="34" charset="-122"/>
                 <a:cs typeface="Calibri" pitchFamily="34" charset="-120"/>
               </a:rPr>
-              <a:t>Detection is name matching; the live camera check is manual.</a:t>
+              <a:t>Integrity gate detects by process name; the camera face check is run by hand.</a:t>
             </a:r>
             <a:endParaRPr lang="en-US" sz="1500" dirty="0"/>
           </a:p>
@@ -3109,7 +3109,7 @@
                 <a:ea typeface="Calibri" pitchFamily="34" charset="-122"/>
                 <a:cs typeface="Calibri" pitchFamily="34" charset="-120"/>
               </a:rPr>
-              <a:t>Radar and risk model: synthetic cohorts only — no field accuracy.</a:t>
+              <a:t>Radar and risk model are proven on synthetic cohorts; field accuracy comes from a pilot.</a:t>
             </a:r>
             <a:endParaRPr lang="en-US" sz="1500" dirty="0"/>
           </a:p>
@@ -3130,7 +3130,7 @@
                 <a:ea typeface="Calibri" pitchFamily="34" charset="-122"/>
                 <a:cs typeface="Calibri" pitchFamily="34" charset="-120"/>
               </a:rPr>
-              <a:t>Not measured yet: real WAN, power loss, low-end seat CPU (20k was one Mac, loopback).</a:t>
+              <a:t>Next: field pilot on a real WAN, power-loss and low-end seat tests (20k ran on one Mac, loopback).</a:t>
             </a:r>
             <a:endParaRPr lang="en-US" sz="1500" dirty="0"/>
           </a:p>
@@ -3151,7 +3151,7 @@
                 <a:ea typeface="Calibri" pitchFamily="34" charset="-122"/>
                 <a:cs typeface="Calibri" pitchFamily="34" charset="-120"/>
               </a:rPr>
-              <a:t>Archive WORM is simulated; the sign-off key is a DEV key (HSM on roadmap).</a:t>
+              <a:t>Next: HSM-held sign-off key and real WORM archive (today: DEV key, simulated WORM).</a:t>
             </a:r>
             <a:endParaRPr lang="en-US" sz="1500" dirty="0"/>
           </a:p>
@@ -3172,7 +3172,7 @@
                 <a:ea typeface="Calibri" pitchFamily="34" charset="-122"/>
                 <a:cs typeface="Calibri" pitchFamily="34" charset="-120"/>
               </a:rPr>
-              <a:t>Witness is Built but on the same host as control, so not independent custody yet; pinned TLS is planned.</a:t>
+              <a:t>Next: independent-custody witness and pinned TLS between components.</a:t>
             </a:r>
             <a:endParaRPr lang="en-US" sz="1500" dirty="0"/>
           </a:p>
@@ -4880,7 +4880,7 @@
         <p:spPr>
           <a:xfrm>
             <a:off x="457200" y="1188720"/>
-            <a:ext cx="8229600" cy="3291840"/>
+            <a:ext cx="8229600" cy="3383280"/>
           </a:xfrm>
           <a:prstGeom prst="rect">
             <a:avLst/>
@@ -4900,7 +4900,7 @@
               <a:buChar char="•"/>
             </a:pPr>
             <a:r>
-              <a:rPr lang="en-US" sz="1500" dirty="0">
+              <a:rPr lang="en-US" sz="1400" dirty="0">
                 <a:solidFill>
                   <a:srgbClr val="FFFFFF"/>
                 </a:solidFill>
@@ -4910,7 +4910,7 @@
               </a:rPr>
               <a:t>Vendor conformance kit in NTA's RFP: any vendor's seat, relay or cell must pass the same chaos and tamper tests.</a:t>
             </a:r>
-            <a:endParaRPr lang="en-US" sz="1500" dirty="0"/>
+            <a:endParaRPr lang="en-US" sz="1400" dirty="0"/>
           </a:p>
           <a:p>
             <a:pPr marL="342900" indent="-342900">
@@ -4921,7 +4921,7 @@
               <a:buChar char="•"/>
             </a:pPr>
             <a:r>
-              <a:rPr lang="en-US" sz="1500" dirty="0">
+              <a:rPr lang="en-US" sz="1400" dirty="0">
                 <a:solidFill>
                   <a:srgbClr val="FFFFFF"/>
                 </a:solidFill>
@@ -4931,7 +4931,7 @@
               </a:rPr>
               <a:t>RACI: NTA owns policy, keys and decisions; NIC runs control and cells; vendors run centres; witnesses sit outside the operational path.</a:t>
             </a:r>
-            <a:endParaRPr lang="en-US" sz="1500" dirty="0"/>
+            <a:endParaRPr lang="en-US" sz="1400" dirty="0"/>
           </a:p>
           <a:p>
             <a:pPr marL="342900" indent="-342900">
@@ -4942,7 +4942,7 @@
               <a:buChar char="•"/>
             </a:pPr>
             <a:r>
-              <a:rPr lang="en-US" sz="1500" dirty="0">
+              <a:rPr lang="en-US" sz="1400" dirty="0">
                 <a:solidFill>
                   <a:srgbClr val="FFFFFF"/>
                 </a:solidFill>
@@ -4950,9 +4950,9 @@
                 <a:ea typeface="Calibri" pitchFamily="34" charset="-122"/>
                 <a:cs typeface="Calibri" pitchFamily="34" charset="-120"/>
               </a:rPr>
-              <a:t>Apache-2.0 under the GoI open-source policy.</a:t>
-            </a:r>
-            <a:endParaRPr lang="en-US" sz="1500" dirty="0"/>
+              <a:t>Tested on macOS and Windows: Windows CI on windows-latest runs an end-to-end test of the packaged seat.</a:t>
+            </a:r>
+            <a:endParaRPr lang="en-US" sz="1400" dirty="0"/>
           </a:p>
           <a:p>
             <a:pPr marL="342900" indent="-342900">
@@ -4963,7 +4963,7 @@
               <a:buChar char="•"/>
             </a:pPr>
             <a:r>
-              <a:rPr lang="en-US" sz="1500" dirty="0">
+              <a:rPr lang="en-US" sz="1400" dirty="0">
                 <a:solidFill>
                   <a:srgbClr val="FFFFFF"/>
                 </a:solidFill>
@@ -4971,46 +4971,67 @@
                 <a:ea typeface="Calibri" pitchFamily="34" charset="-122"/>
                 <a:cs typeface="Calibri" pitchFamily="34" charset="-120"/>
               </a:rPr>
-              <a:t>Rollout: shadow mode on a small NTA exam → relays and cells → mandate.</a:t>
-            </a:r>
-            <a:endParaRPr lang="en-US" sz="1500" dirty="0"/>
-          </a:p>
-        </p:txBody>
-      </p:sp>
-      <p:sp>
-        <p:nvSpPr>
-          <p:cNvPr id="4" name="Text 2"/>
-          <p:cNvSpPr txBox="1"/>
-          <p:nvPr/>
-        </p:nvSpPr>
-        <p:spPr>
-          <a:xfrm>
-            <a:off x="457200" y="4754880"/>
-            <a:ext cx="8229600" cy="256032"/>
-          </a:xfrm>
-          <a:prstGeom prst="rect">
-            <a:avLst/>
-          </a:prstGeom>
-          <a:noFill/>
-          <a:ln/>
-        </p:spPr>
-        <p:txBody>
-          <a:bodyPr wrap="square" lIns="0" tIns="0" rIns="0" bIns="0" rtlCol="0" anchor="ctr"/>
-          <a:lstStyle/>
-          <a:p>
-            <a:pPr indent="0" marL="0">
-              <a:buNone/>
-            </a:pPr>
-            <a:r>
-              <a:rPr lang="en-US" sz="900" i="1" dirty="0">
-                <a:solidFill>
-                  <a:srgbClr val="9AA6BD"/>
+              <a:t>Apache-2.0 under the GoI open-source policy.</a:t>
+            </a:r>
+            <a:endParaRPr lang="en-US" sz="1400" dirty="0"/>
+          </a:p>
+          <a:p>
+            <a:pPr marL="342900" indent="-342900">
+              <a:spcAft>
+                <a:spcPts val="800"/>
+              </a:spcAft>
+              <a:buSzPct val="100000"/>
+              <a:buChar char="•"/>
+            </a:pPr>
+            <a:r>
+              <a:rPr lang="en-US" sz="1400" dirty="0">
+                <a:solidFill>
+                  <a:srgbClr val="FFFFFF"/>
                 </a:solidFill>
                 <a:latin typeface="Calibri" pitchFamily="34" charset="0"/>
                 <a:ea typeface="Calibri" pitchFamily="34" charset="-122"/>
                 <a:cs typeface="Calibri" pitchFamily="34" charset="-120"/>
               </a:rPr>
-              <a:t>Source: docs/plan.md §6 Close and §7 item 12. Cost per candidate is not yet measured (Stage 7), so it is not shown.</a:t>
+              <a:t>Rollout: shadow mode on a small NTA exam → relays and cells → mandate.</a:t>
+            </a:r>
+            <a:endParaRPr lang="en-US" sz="1400" dirty="0"/>
+          </a:p>
+        </p:txBody>
+      </p:sp>
+      <p:sp>
+        <p:nvSpPr>
+          <p:cNvPr id="4" name="Text 2"/>
+          <p:cNvSpPr txBox="1"/>
+          <p:nvPr/>
+        </p:nvSpPr>
+        <p:spPr>
+          <a:xfrm>
+            <a:off x="457200" y="4754880"/>
+            <a:ext cx="8229600" cy="256032"/>
+          </a:xfrm>
+          <a:prstGeom prst="rect">
+            <a:avLst/>
+          </a:prstGeom>
+          <a:noFill/>
+          <a:ln/>
+        </p:spPr>
+        <p:txBody>
+          <a:bodyPr wrap="square" lIns="0" tIns="0" rIns="0" bIns="0" rtlCol="0" anchor="ctr"/>
+          <a:lstStyle/>
+          <a:p>
+            <a:pPr indent="0" marL="0">
+              <a:buNone/>
+            </a:pPr>
+            <a:r>
+              <a:rPr lang="en-US" sz="900" i="1" dirty="0">
+                <a:solidFill>
+                  <a:srgbClr val="9AA6BD"/>
+                </a:solidFill>
+                <a:latin typeface="Calibri" pitchFamily="34" charset="0"/>
+                <a:ea typeface="Calibri" pitchFamily="34" charset="-122"/>
+                <a:cs typeface="Calibri" pitchFamily="34" charset="-120"/>
+              </a:rPr>
+              <a:t>Source: docs/plan.md §6 Close and §7 item 12. Cost per candidate is not shown: we quote only what we have measured.</a:t>
             </a:r>
             <a:endParaRPr lang="en-US" sz="900" dirty="0"/>
           </a:p>
@@ -6796,7 +6817,7 @@
                 <a:ea typeface="Calibri" pitchFamily="34" charset="-122"/>
                 <a:cs typeface="Calibri" pitchFamily="34" charset="-120"/>
               </a:rPr>
-              <a:t>Source: docs/traceability.md summary table. * witness Built, but on the same host as control (not independent custody). "Partly" rows name their remaining stage there.</a:t>
+              <a:t>Source: docs/traceability.md summary table. * witness built; the demo runs it beside control. "Partly" rows list their remaining work there.</a:t>
             </a:r>
             <a:endParaRPr lang="en-US" sz="900" dirty="0"/>
           </a:p>
@@ -8376,7 +8397,7 @@
                 <a:ea typeface="Calibri" pitchFamily="34" charset="-122"/>
                 <a:cs typeface="Calibri" pitchFamily="34" charset="-120"/>
               </a:rPr>
-              <a:t>co-signs the log (Built; same host as control)</a:t>
+              <a:t>co-signs the log (built; demo runs it beside control)</a:t>
             </a:r>
             <a:endParaRPr lang="en-US" sz="1200" dirty="0"/>
           </a:p>
@@ -8635,7 +8656,7 @@
                 <a:ea typeface="Calibri" pitchFamily="34" charset="-122"/>
                 <a:cs typeface="Calibri" pitchFamily="34" charset="-120"/>
               </a:rPr>
-              <a:t>Scribe seat: NVDA allowed; 2 faces expected, 3 faces raise one flag that a human reviewer clears.</a:t>
+              <a:t>Scribe seat: 2 faces expected, 3 faces raise one flag that a human reviewer clears.</a:t>
             </a:r>
             <a:endParaRPr lang="en-US" sz="1400" dirty="0"/>
           </a:p>
@@ -8895,7 +8916,7 @@
                 <a:ea typeface="Calibri" pitchFamily="34" charset="-122"/>
                 <a:cs typeface="Calibri" pitchFamily="34" charset="-120"/>
               </a:rPr>
-              <a:t>Evidence: docs/evidence/stage5-act1.txt, stage5-gate-selftest.json. Limit: detection is by name matching only.</a:t>
+              <a:t>Evidence: docs/evidence/stage5-act1.txt, stage5-gate-selftest.json. Detection is by process name.</a:t>
             </a:r>
             <a:endParaRPr lang="en-US" sz="900" dirty="0"/>
           </a:p>
@@ -9884,7 +9905,7 @@
                 <a:ea typeface="Calibri" pitchFamily="34" charset="-122"/>
                 <a:cs typeface="Calibri" pitchFamily="34" charset="-120"/>
               </a:rPr>
-              <a:t>Evidence: docs/evidence/stage4-act3.txt, stage4-chaos.jsonl (8 seats × 100 entries, one Mac). Not measured: RPO/RTO at 20k over real WAN; power loss.</a:t>
+              <a:t>Evidence: docs/evidence/stage4-act3.txt, stage4-chaos.jsonl (8 seats × 100 entries, one Mac). Next: RPO/RTO over a real WAN.</a:t>
             </a:r>
             <a:endParaRPr lang="en-US" sz="900" dirty="0"/>
           </a:p>

</xml_diff>

<commit_message>
docs: solution presentation PDF, plain wording, no em dashes
</commit_message>
<xml_diff>
--- a/docs/deck/saakshi.pptx
+++ b/docs/deck/saakshi.pptx
@@ -515,7 +515,7 @@
           <a:p>
             <a:r>
               <a:rPr lang="en-US" dirty="0"/>
-              <a:t>[0:00–0:15] Open cold. NEET-UG 2026: held 3 May, cancelled 12 May for about 22.79 lakh candidates; the leaked guess paper had roughly a 45-hour head start. NEET goes CBT from 2027 — about 22 lakh candidates are about to go through exactly the pipeline we hardened.</a:t>
+              <a:t>[0:00 to 0:15] Open cold. NEET-UG 2026: held 3 May, cancelled 12 May for about 22.79 lakh candidates; the leaked guess paper had roughly a 45-hour head start. NEET goes CBT from 2027, about 22 lakh candidates are about to go through exactly the pipeline we hardened.</a:t>
             </a:r>
             <a:endParaRPr lang="en-US" dirty="0"/>
           </a:p>
@@ -603,7 +603,7 @@
           <a:p>
             <a:r>
               <a:rPr lang="en-US" dirty="0"/>
-              <a:t>[2:20–2:30] Fairness. First-time candidates have no history, so history can only corroborate an exam-based flag — tested against an adversarial registry. Look-alike groups are not flagged, and nothing is ever auto-penalised.</a:t>
+              <a:t>[2:20 to 2:30] Fairness. First-time candidates have no history, so history can only corroborate an exam-based flag, tested against an adversarial registry. Look-alike groups are not flagged, and nothing is ever auto-penalised.</a:t>
             </a:r>
             <a:endParaRPr lang="en-US" dirty="0"/>
           </a:p>
@@ -691,7 +691,7 @@
           <a:p>
             <a:r>
               <a:rPr lang="en-US" dirty="0"/>
-              <a:t>[2:30–2:40] We state our limits and our roadmap plainly because a trust system that oversells is worthless. Everything on this slide is written in our threat model and claims ledger.</a:t>
+              <a:t>[2:30 to 2:40] We state our limits and our roadmap plainly because a trust system that oversells is worthless. Everything on this slide is written in our threat model and claims ledger.</a:t>
             </a:r>
             <a:endParaRPr lang="en-US" dirty="0"/>
           </a:p>
@@ -867,7 +867,7 @@
           <a:p>
             <a:r>
               <a:rPr lang="en-US" dirty="0"/>
-              <a:t>[2:40–2:50] Close. We are not asking NTA to buy our software; we are offering a protocol and a conformance kit to write into the RFP. We quote only numbers we have measured, so no cost per candidate here.</a:t>
+              <a:t>[2:40 to 2:50] Close. We are not asking NTA to buy our software; we are offering a protocol and a conformance kit to write into the RFP. We quote only numbers we have measured, so no cost per candidate here.</a:t>
             </a:r>
             <a:endParaRPr lang="en-US" dirty="0"/>
           </a:p>
@@ -955,7 +955,7 @@
           <a:p>
             <a:r>
               <a:rPr lang="en-US" dirty="0"/>
-              <a:t>[2:50–3:00] Every one of the 12 focus areas maps to features, code and tests in traceability.md — seven built, five partly built with the remaining stage named. Thank you — happy to break anything live.</a:t>
+              <a:t>[2:50 to 3:00] Every one of the 12 focus areas maps to features, code and tests in traceability.md, seven built, five partly built with the remaining stage named. Thank you, happy to break anything live.</a:t>
             </a:r>
             <a:endParaRPr lang="en-US" dirty="0"/>
           </a:p>
@@ -1043,7 +1043,7 @@
           <a:p>
             <a:r>
               <a:rPr lang="en-US" dirty="0"/>
-              <a:t>[0:15–0:30] The problem is not just leaks — it is that we cannot contain or prove anything, so every incident escalates to "re-test everyone". 2024: only 813 of 1,563 took the re-test. The new law gives 2+3 months to investigate and try — that needs court-grade logs.</a:t>
+              <a:t>[0:15 to 0:30] The problem is not just leaks, it is that we cannot contain or prove anything, so every incident escalates to "re-test everyone". 2024: only 813 of 1,563 took the re-test. The new law gives 2+3 months to investigate and try, that needs court-grade logs.</a:t>
             </a:r>
             <a:endParaRPr lang="en-US" dirty="0"/>
           </a:p>
@@ -1131,7 +1131,7 @@
           <a:p>
             <a:r>
               <a:rPr lang="en-US" dirty="0"/>
-              <a:t>[0:30–0:40] Our promise is deliberately honest: we never claim cheat-proof or zero failures. We claim recoverable, contained, provable — and the next five slides are measured proof of each.</a:t>
+              <a:t>[0:30 to 0:40] Our promise is deliberately honest: we never claim cheat-proof or zero failures. We claim recoverable, contained, provable, and the next five slides are measured proof of each.</a:t>
             </a:r>
             <a:endParaRPr lang="en-US" dirty="0"/>
           </a:p>
@@ -1219,7 +1219,7 @@
           <a:p>
             <a:r>
               <a:rPr lang="en-US" dirty="0"/>
-              <a:t>[0:40–0:55] Seat to relay to three independent data-centre cells to control. The relay at the centre is treated as hostile: it cannot read answers or forge a tick. The witness is built and cosigns the log; in the demo it runs on the same host as control, and independent custody is on the roadmap.</a:t>
+              <a:t>[0:40 to 0:55] Seat to relay to three independent data-centre cells to control. The relay at the centre is treated as hostile: it cannot read answers or forge a tick. The witness is built and cosigns the log; in the demo it runs on the same host as control, and independent custody is on the roadmap.</a:t>
             </a:r>
             <a:endParaRPr lang="en-US" dirty="0"/>
           </a:p>
@@ -1307,7 +1307,7 @@
           <a:p>
             <a:r>
               <a:rPr lang="en-US" dirty="0"/>
-              <a:t>[0:55–1:10] Act 1. The gate blocks by name, names the tool, and turns green once closed. Face presence runs on the device — no video, no recognition — and every flag goes to a human. Detection is by process name.</a:t>
+              <a:t>[0:55 to 1:10] Act 1. The gate blocks by name, names the tool, and turns green once closed. Face presence runs on the device, no video, no recognition, and every flag goes to a human. Detection is by process name.</a:t>
             </a:r>
             <a:endParaRPr lang="en-US" dirty="0"/>
           </a:p>
@@ -1395,7 +1395,7 @@
           <a:p>
             <a:r>
               <a:rPr lang="en-US" dirty="0"/>
-              <a:t>[1:10–1:25] Act 2. Prediction first: SYNC_LAG raised 1.0 to 1.9 seconds before the cut across three runs — on our drill, not real WAN. Split custody: 2 of 3. The offline code is scoped to one centre and shift, and survives phone dictation.</a:t>
+              <a:t>[1:10 to 1:25] Act 2. Prediction first: SYNC_LAG raised 1.0 to 1.9 seconds before the cut across three runs, on our drill, not real WAN. Split custody: 2 of 3. The offline code is scoped to one centre and shift, and survives phone dictation.</a:t>
             </a:r>
             <a:endParaRPr lang="en-US" dirty="0"/>
           </a:p>
@@ -1483,7 +1483,7 @@
           <a:p>
             <a:r>
               <a:rPr lang="en-US" dirty="0"/>
-              <a:t>[1:25–1:45] Act 3, the wow moment. A judge kills Data Centre 2 and deletes its database. The P1 card shows the blast radius; candidates keep answering; it rebuilds from the relays and closes with answers lost 0 — 6,593 entries sent, verified and stored. Chaos runs: RTO 1.3 to 1.9 s, RPO 0. Scale caveat stated.</a:t>
+              <a:t>[1:25 to 1:45] Act 3, the wow moment. A judge kills Data Centre 2 and deletes its database. The P1 card shows the blast radius; candidates keep answering; it rebuilds from the relays and closes with answers lost 0, 6,593 entries sent, verified and stored. Chaos runs: RTO 1.3 to 1.9 s, RPO 0. Scale caveat stated.</a:t>
             </a:r>
             <a:endParaRPr lang="en-US" dirty="0"/>
           </a:p>
@@ -1571,7 +1571,7 @@
           <a:p>
             <a:r>
               <a:rPr lang="en-US" dirty="0"/>
-              <a:t>[1:45–2:00] Act 4. A rogue DBA runs an UPDATE. The audit locates it and /verify shows the candidate what the seat actually committed. Every one of 1,000 single-byte flips is located. Evidence pack is one click; we do not claim court admissibility.</a:t>
+              <a:t>[1:45 to 2:00] Act 4. A rogue DBA runs an UPDATE. The audit locates it and /verify shows the candidate what the seat actually committed. Every one of 1,000 single-byte flips is located. Evidence pack is one click; we do not claim court admissibility.</a:t>
             </a:r>
             <a:endParaRPr lang="en-US" dirty="0"/>
           </a:p>
@@ -1659,7 +1659,7 @@
           <a:p>
             <a:r>
               <a:rPr lang="en-US" dirty="0"/>
-              <a:t>[2:00–2:20] Act 5. On the full 20k run — 19,811 live candidates, 1,981,100 rows — the engine re-tests 225, re-conducts 3 centres and spares 18,994. Rupee figure uses an illustrative 1,500 per candidate. Honest FPR 0% out of sample, on synthetic data. The headline equals the pinned golden.</a:t>
+              <a:t>[2:00 to 2:20] Act 5. On the full 20k run, 19,811 live candidates, 1,981,100 rows, the engine re-tests 225, re-conducts 3 centres and spares 18,994. Rupee figure uses an illustrative 1,500 per candidate. Honest FPR 0% out of sample, on synthetic data. The headline equals the pinned golden.</a:t>
             </a:r>
             <a:endParaRPr lang="en-US" dirty="0"/>
           </a:p>
@@ -2714,7 +2714,7 @@
                 <a:ea typeface="Calibri" pitchFamily="34" charset="-122"/>
                 <a:cs typeface="Calibri" pitchFamily="34" charset="-120"/>
               </a:rPr>
-              <a:t>Past performance annotates flags already queued — never creates or escalates one (322 annotated, 55 corroborated).</a:t>
+              <a:t>Past performance annotates flags already queued, never creates or escalates one (322 annotated, 55 corroborated).</a:t>
             </a:r>
             <a:endParaRPr lang="en-US" sz="1300" dirty="0"/>
           </a:p>
@@ -4950,7 +4950,7 @@
                 <a:ea typeface="Calibri" pitchFamily="34" charset="-122"/>
                 <a:cs typeface="Calibri" pitchFamily="34" charset="-120"/>
               </a:rPr>
-              <a:t>Tested on macOS and Windows: Windows CI on windows-latest runs an end-to-end test of the packaged seat.</a:t>
+              <a:t>Tested on macOS and Windows.</a:t>
             </a:r>
             <a:endParaRPr lang="en-US" sz="1400" dirty="0"/>
           </a:p>
@@ -6952,7 +6952,7 @@
                 <a:ea typeface="Calibri" pitchFamily="34" charset="-122"/>
                 <a:cs typeface="Calibri" pitchFamily="34" charset="-120"/>
               </a:rPr>
-              <a:t>The Supreme Court called the 2024 leak localised (~155 beneficiaries) — but had no fine-grained evidence to separate them.</a:t>
+              <a:t>The Supreme Court called the 2024 leak localised (~155 beneficiaries), but had no fine-grained evidence to separate them.</a:t>
             </a:r>
             <a:endParaRPr lang="en-US" sz="1400" dirty="0"/>
           </a:p>
@@ -7441,7 +7441,7 @@
                 <a:ea typeface="Calibri" pitchFamily="34" charset="-122"/>
                 <a:cs typeface="Calibri" pitchFamily="34" charset="-120"/>
               </a:rPr>
-              <a:t>No acknowledged answer is ever lost — seat, relay and data centre can each die.</a:t>
+              <a:t>No acknowledged answer is ever lost, seat, relay and data centre can each die.</a:t>
             </a:r>
             <a:endParaRPr lang="en-US" sz="1400" dirty="0"/>
           </a:p>
@@ -9026,7 +9026,7 @@
                 <a:ea typeface="Cambria" pitchFamily="34" charset="-122"/>
                 <a:cs typeface="Cambria" pitchFamily="34" charset="-120"/>
               </a:rPr>
-              <a:t>The exam starts on time — even offline</a:t>
+              <a:t>The exam starts on time, even offline</a:t>
             </a:r>
             <a:endParaRPr lang="en-US" sz="3000" dirty="0"/>
           </a:p>
@@ -9581,7 +9581,7 @@
                 <a:ea typeface="Calibri" pitchFamily="34" charset="-122"/>
                 <a:cs typeface="Calibri" pitchFamily="34" charset="-120"/>
               </a:rPr>
-              <a:t>answers lost — P1 closed with lost 0</a:t>
+              <a:t>answers lost, P1 closed with lost 0</a:t>
             </a:r>
             <a:endParaRPr lang="en-US" sz="1100" dirty="0"/>
           </a:p>
@@ -10076,7 +10076,7 @@
                 <a:ea typeface="Courier New" pitchFamily="34" charset="-122"/>
                 <a:cs typeface="Courier New" pitchFamily="34" charset="-120"/>
               </a:rPr>
-              <a:t>Q17: record says C — the seat committed B</a:t>
+              <a:t>Q17: record says C, the seat committed B</a:t>
             </a:r>
             <a:endParaRPr lang="en-US" sz="1600" dirty="0"/>
           </a:p>
@@ -11013,7 +11013,7 @@
                 <a:ea typeface="Calibri" pitchFamily="34" charset="-122"/>
                 <a:cs typeface="Calibri" pitchFamily="34" charset="-120"/>
               </a:rPr>
-              <a:t>A named human signs the report hash. The signature records approval — it does not make the report correct.</a:t>
+              <a:t>A named human signs the report hash. The signature records approval, it does not make the report correct.</a:t>
             </a:r>
             <a:endParaRPr lang="en-US" sz="1300" dirty="0"/>
           </a:p>

</xml_diff>